<commit_message>
Refine PowerPoint presentation generation script for MUST partnership pitch. Adjusted header dimensions and improved text formatting for kicker and title handling. Enhanced layout for better readability and visual appeal in the generated slides.
</commit_message>
<xml_diff>
--- a/pitch-presentations/documents/must_ppt.pptx
+++ b/pitch-presentations/documents/must_ppt.pptx
@@ -4908,8 +4908,62 @@
         </p:nvSpPr>
         <p:spPr>
           <a:xfrm>
-            <a:off x="502920" y="146304"/>
-            <a:ext cx="9845942" cy="292608"/>
+            <a:off x="502920" y="256032"/>
+            <a:ext cx="9845942" cy="566928"/>
+          </a:xfrm>
+          <a:prstGeom prst="rect">
+            <a:avLst/>
+          </a:prstGeom>
+          <a:noFill/>
+        </p:spPr>
+        <p:txBody>
+          <a:bodyPr wrap="square" lIns="18000" rIns="18000" tIns="4000" bIns="4000" anchor="ctr">
+            <a:spAutoFit/>
+          </a:bodyPr>
+          <a:lstStyle/>
+          <a:p>
+            <a:pPr algn="l">
+              <a:lnSpc>
+                <a:spcPct val="115000"/>
+              </a:lnSpc>
+              <a:spcBef>
+                <a:spcPts val="0"/>
+              </a:spcBef>
+              <a:spcAft>
+                <a:spcPts val="0"/>
+              </a:spcAft>
+            </a:pPr>
+            <a:r>
+              <a:rPr sz="2800" b="1">
+                <a:solidFill>
+                  <a:srgbClr val="C45C26"/>
+                </a:solidFill>
+                <a:latin typeface="Calibri"/>
+              </a:rPr>
+              <a:t>Purpose: </a:t>
+            </a:r>
+            <a:r>
+              <a:rPr sz="2800" b="1">
+                <a:solidFill>
+                  <a:srgbClr val="0A1F2E"/>
+                </a:solidFill>
+                <a:latin typeface="Calibri"/>
+              </a:rPr>
+              <a:t>Why we are here</a:t>
+            </a:r>
+          </a:p>
+        </p:txBody>
+      </p:sp>
+      <p:sp>
+        <p:nvSpPr>
+          <p:cNvPr id="8" name="TextBox 7"/>
+          <p:cNvSpPr txBox="1"/>
+          <p:nvPr/>
+        </p:nvSpPr>
+        <p:spPr>
+          <a:xfrm>
+            <a:off x="502920" y="960120"/>
+            <a:ext cx="11185855" cy="1097280"/>
           </a:xfrm>
           <a:prstGeom prst="rect">
             <a:avLst/>
@@ -4930,42 +4984,19 @@
                 <a:spcPts val="0"/>
               </a:spcBef>
               <a:spcAft>
-                <a:spcPts val="0"/>
+                <a:spcPts val="1000"/>
               </a:spcAft>
             </a:pPr>
             <a:r>
-              <a:rPr sz="1700" b="1">
-                <a:solidFill>
-                  <a:srgbClr val="C45C26"/>
-                </a:solidFill>
-                <a:latin typeface="Calibri"/>
-              </a:rPr>
-              <a:t>PURPOSE</a:t>
-            </a:r>
-          </a:p>
-        </p:txBody>
-      </p:sp>
-      <p:sp>
-        <p:nvSpPr>
-          <p:cNvPr id="8" name="TextBox 7"/>
-          <p:cNvSpPr txBox="1"/>
-          <p:nvPr/>
-        </p:nvSpPr>
-        <p:spPr>
-          <a:xfrm>
-            <a:off x="502920" y="402336"/>
-            <a:ext cx="9845942" cy="530352"/>
-          </a:xfrm>
-          <a:prstGeom prst="rect">
-            <a:avLst/>
-          </a:prstGeom>
-          <a:noFill/>
-        </p:spPr>
-        <p:txBody>
-          <a:bodyPr wrap="square" lIns="22000" rIns="22000" tIns="8000" bIns="8000" anchor="t">
-            <a:spAutoFit/>
-          </a:bodyPr>
-          <a:lstStyle/>
+              <a:rPr sz="2200" b="0">
+                <a:solidFill>
+                  <a:srgbClr val="1E2F38"/>
+                </a:solidFill>
+                <a:latin typeface="Calibri"/>
+              </a:rPr>
+              <a:t>FairBanks Medical Centre seeks a practical partnership with MUST —</a:t>
+            </a:r>
+          </a:p>
           <a:p>
             <a:pPr algn="l">
               <a:lnSpc>
@@ -4975,42 +5006,19 @@
                 <a:spcPts val="0"/>
               </a:spcBef>
               <a:spcAft>
-                <a:spcPts val="0"/>
+                <a:spcPts val="1000"/>
               </a:spcAft>
             </a:pPr>
             <a:r>
-              <a:rPr sz="3200" b="1">
-                <a:solidFill>
-                  <a:srgbClr val="0A1F2E"/>
-                </a:solidFill>
-                <a:latin typeface="Calibri"/>
-              </a:rPr>
-              <a:t>Why we are here</a:t>
-            </a:r>
-          </a:p>
-        </p:txBody>
-      </p:sp>
-      <p:sp>
-        <p:nvSpPr>
-          <p:cNvPr id="9" name="TextBox 8"/>
-          <p:cNvSpPr txBox="1"/>
-          <p:nvPr/>
-        </p:nvSpPr>
-        <p:spPr>
-          <a:xfrm>
-            <a:off x="502920" y="1097280"/>
-            <a:ext cx="11185855" cy="1097280"/>
-          </a:xfrm>
-          <a:prstGeom prst="rect">
-            <a:avLst/>
-          </a:prstGeom>
-          <a:noFill/>
-        </p:spPr>
-        <p:txBody>
-          <a:bodyPr wrap="square" lIns="22000" rIns="22000" tIns="8000" bIns="8000" anchor="t">
-            <a:spAutoFit/>
-          </a:bodyPr>
-          <a:lstStyle/>
+              <a:rPr sz="2200" b="0">
+                <a:solidFill>
+                  <a:srgbClr val="1E2F38"/>
+                </a:solidFill>
+                <a:latin typeface="Calibri"/>
+              </a:rPr>
+              <a:t>linking a working clinic and community programmes with university teaching,</a:t>
+            </a:r>
+          </a:p>
           <a:p>
             <a:pPr algn="l">
               <a:lnSpc>
@@ -5030,50 +5038,6 @@
                 </a:solidFill>
                 <a:latin typeface="Calibri"/>
               </a:rPr>
-              <a:t>FairBanks Medical Centre seeks a practical partnership with MUST —</a:t>
-            </a:r>
-          </a:p>
-          <a:p>
-            <a:pPr algn="l">
-              <a:lnSpc>
-                <a:spcPct val="150000"/>
-              </a:lnSpc>
-              <a:spcBef>
-                <a:spcPts val="0"/>
-              </a:spcBef>
-              <a:spcAft>
-                <a:spcPts val="1000"/>
-              </a:spcAft>
-            </a:pPr>
-            <a:r>
-              <a:rPr sz="2200" b="0">
-                <a:solidFill>
-                  <a:srgbClr val="1E2F38"/>
-                </a:solidFill>
-                <a:latin typeface="Calibri"/>
-              </a:rPr>
-              <a:t>linking a working clinic and community programmes with university teaching,</a:t>
-            </a:r>
-          </a:p>
-          <a:p>
-            <a:pPr algn="l">
-              <a:lnSpc>
-                <a:spcPct val="150000"/>
-              </a:lnSpc>
-              <a:spcBef>
-                <a:spcPts val="0"/>
-              </a:spcBef>
-              <a:spcAft>
-                <a:spcPts val="1000"/>
-              </a:spcAft>
-            </a:pPr>
-            <a:r>
-              <a:rPr sz="2200" b="0">
-                <a:solidFill>
-                  <a:srgbClr val="1E2F38"/>
-                </a:solidFill>
-                <a:latin typeface="Calibri"/>
-              </a:rPr>
               <a:t>research, innovation, and grant writing.</a:t>
             </a:r>
           </a:p>
@@ -5081,14 +5045,14 @@
       </p:sp>
       <p:sp>
         <p:nvSpPr>
-          <p:cNvPr id="10" name="Rounded Rectangle 9"/>
+          <p:cNvPr id="9" name="Rounded Rectangle 8"/>
           <p:cNvSpPr/>
           <p:nvPr/>
         </p:nvSpPr>
         <p:spPr>
           <a:xfrm>
-            <a:off x="502920" y="2331720"/>
-            <a:ext cx="11185855" cy="1155192"/>
+            <a:off x="502920" y="2194560"/>
+            <a:ext cx="11185855" cy="1200912"/>
           </a:xfrm>
           <a:prstGeom prst="roundRect">
             <a:avLst>
@@ -5129,14 +5093,14 @@
       </p:sp>
       <p:sp>
         <p:nvSpPr>
-          <p:cNvPr id="11" name="Rectangle 10"/>
+          <p:cNvPr id="10" name="Rectangle 9"/>
           <p:cNvSpPr/>
           <p:nvPr/>
         </p:nvSpPr>
         <p:spPr>
           <a:xfrm>
-            <a:off x="667512" y="2459736"/>
-            <a:ext cx="91440" cy="899160"/>
+            <a:off x="667512" y="2322576"/>
+            <a:ext cx="91440" cy="944879"/>
           </a:xfrm>
           <a:prstGeom prst="rect">
             <a:avLst/>
@@ -5173,13 +5137,13 @@
       </p:sp>
       <p:sp>
         <p:nvSpPr>
-          <p:cNvPr id="12" name="TextBox 11"/>
+          <p:cNvPr id="11" name="TextBox 10"/>
           <p:cNvSpPr txBox="1"/>
           <p:nvPr/>
         </p:nvSpPr>
         <p:spPr>
           <a:xfrm>
-            <a:off x="914400" y="2441448"/>
+            <a:off x="914400" y="2304288"/>
             <a:ext cx="10500055" cy="384048"/>
           </a:xfrm>
           <a:prstGeom prst="rect">
@@ -5218,14 +5182,14 @@
       </p:sp>
       <p:sp>
         <p:nvSpPr>
-          <p:cNvPr id="13" name="TextBox 12"/>
+          <p:cNvPr id="12" name="TextBox 11"/>
           <p:cNvSpPr txBox="1"/>
           <p:nvPr/>
         </p:nvSpPr>
         <p:spPr>
           <a:xfrm>
-            <a:off x="914400" y="2862072"/>
-            <a:ext cx="10500055" cy="496824"/>
+            <a:off x="914400" y="2724912"/>
+            <a:ext cx="10500055" cy="542543"/>
           </a:xfrm>
           <a:prstGeom prst="rect">
             <a:avLst/>
@@ -5263,14 +5227,14 @@
       </p:sp>
       <p:sp>
         <p:nvSpPr>
-          <p:cNvPr id="14" name="Rounded Rectangle 13"/>
+          <p:cNvPr id="13" name="Rounded Rectangle 12"/>
           <p:cNvSpPr/>
           <p:nvPr/>
         </p:nvSpPr>
         <p:spPr>
           <a:xfrm>
-            <a:off x="502920" y="3614928"/>
-            <a:ext cx="11185855" cy="1155192"/>
+            <a:off x="502920" y="3523488"/>
+            <a:ext cx="11185855" cy="1200912"/>
           </a:xfrm>
           <a:prstGeom prst="roundRect">
             <a:avLst>
@@ -5311,14 +5275,14 @@
       </p:sp>
       <p:sp>
         <p:nvSpPr>
-          <p:cNvPr id="15" name="Rectangle 14"/>
+          <p:cNvPr id="14" name="Rectangle 13"/>
           <p:cNvSpPr/>
           <p:nvPr/>
         </p:nvSpPr>
         <p:spPr>
           <a:xfrm>
-            <a:off x="667512" y="3742943"/>
-            <a:ext cx="91440" cy="899160"/>
+            <a:off x="667512" y="3651504"/>
+            <a:ext cx="91440" cy="944879"/>
           </a:xfrm>
           <a:prstGeom prst="rect">
             <a:avLst/>
@@ -5355,13 +5319,13 @@
       </p:sp>
       <p:sp>
         <p:nvSpPr>
-          <p:cNvPr id="16" name="TextBox 15"/>
+          <p:cNvPr id="15" name="TextBox 14"/>
           <p:cNvSpPr txBox="1"/>
           <p:nvPr/>
         </p:nvSpPr>
         <p:spPr>
           <a:xfrm>
-            <a:off x="914400" y="3724656"/>
+            <a:off x="914400" y="3633216"/>
             <a:ext cx="10500055" cy="384048"/>
           </a:xfrm>
           <a:prstGeom prst="rect">
@@ -5400,14 +5364,14 @@
       </p:sp>
       <p:sp>
         <p:nvSpPr>
-          <p:cNvPr id="17" name="TextBox 16"/>
+          <p:cNvPr id="16" name="TextBox 15"/>
           <p:cNvSpPr txBox="1"/>
           <p:nvPr/>
         </p:nvSpPr>
         <p:spPr>
           <a:xfrm>
-            <a:off x="914400" y="4145280"/>
-            <a:ext cx="10500055" cy="496824"/>
+            <a:off x="914400" y="4053840"/>
+            <a:ext cx="10500055" cy="542543"/>
           </a:xfrm>
           <a:prstGeom prst="rect">
             <a:avLst/>
@@ -5445,14 +5409,14 @@
       </p:sp>
       <p:sp>
         <p:nvSpPr>
-          <p:cNvPr id="18" name="Rounded Rectangle 17"/>
+          <p:cNvPr id="17" name="Rounded Rectangle 16"/>
           <p:cNvSpPr/>
           <p:nvPr/>
         </p:nvSpPr>
         <p:spPr>
           <a:xfrm>
-            <a:off x="502920" y="4898136"/>
-            <a:ext cx="11185855" cy="1155192"/>
+            <a:off x="502920" y="4852416"/>
+            <a:ext cx="11185855" cy="1200912"/>
           </a:xfrm>
           <a:prstGeom prst="roundRect">
             <a:avLst>
@@ -5493,14 +5457,14 @@
       </p:sp>
       <p:sp>
         <p:nvSpPr>
-          <p:cNvPr id="19" name="Rectangle 18"/>
+          <p:cNvPr id="18" name="Rectangle 17"/>
           <p:cNvSpPr/>
           <p:nvPr/>
         </p:nvSpPr>
         <p:spPr>
           <a:xfrm>
-            <a:off x="667512" y="5026151"/>
-            <a:ext cx="91440" cy="899160"/>
+            <a:off x="667512" y="4980432"/>
+            <a:ext cx="91440" cy="944879"/>
           </a:xfrm>
           <a:prstGeom prst="rect">
             <a:avLst/>
@@ -5537,13 +5501,13 @@
       </p:sp>
       <p:sp>
         <p:nvSpPr>
-          <p:cNvPr id="20" name="TextBox 19"/>
+          <p:cNvPr id="19" name="TextBox 18"/>
           <p:cNvSpPr txBox="1"/>
           <p:nvPr/>
         </p:nvSpPr>
         <p:spPr>
           <a:xfrm>
-            <a:off x="914400" y="5007864"/>
+            <a:off x="914400" y="4962144"/>
             <a:ext cx="10500055" cy="384048"/>
           </a:xfrm>
           <a:prstGeom prst="rect">
@@ -5582,14 +5546,14 @@
       </p:sp>
       <p:sp>
         <p:nvSpPr>
-          <p:cNvPr id="21" name="TextBox 20"/>
+          <p:cNvPr id="20" name="TextBox 19"/>
           <p:cNvSpPr txBox="1"/>
           <p:nvPr/>
         </p:nvSpPr>
         <p:spPr>
           <a:xfrm>
-            <a:off x="914400" y="5428488"/>
-            <a:ext cx="10500055" cy="496824"/>
+            <a:off x="914400" y="5382768"/>
+            <a:ext cx="10500055" cy="542543"/>
           </a:xfrm>
           <a:prstGeom prst="rect">
             <a:avLst/>
@@ -5627,7 +5591,7 @@
       </p:sp>
       <p:sp>
         <p:nvSpPr>
-          <p:cNvPr id="22" name="Rectangle 21"/>
+          <p:cNvPr id="21" name="Rectangle 20"/>
           <p:cNvSpPr/>
           <p:nvPr/>
         </p:nvSpPr>
@@ -5671,7 +5635,7 @@
       </p:sp>
       <p:sp>
         <p:nvSpPr>
-          <p:cNvPr id="23" name="TextBox 22"/>
+          <p:cNvPr id="22" name="TextBox 21"/>
           <p:cNvSpPr txBox="1"/>
           <p:nvPr/>
         </p:nvSpPr>
@@ -5716,7 +5680,7 @@
       </p:sp>
       <p:sp>
         <p:nvSpPr>
-          <p:cNvPr id="24" name="TextBox 23"/>
+          <p:cNvPr id="23" name="TextBox 22"/>
           <p:cNvSpPr txBox="1"/>
           <p:nvPr/>
         </p:nvSpPr>
@@ -5992,8 +5956,8 @@
         </p:nvSpPr>
         <p:spPr>
           <a:xfrm>
-            <a:off x="502920" y="146304"/>
-            <a:ext cx="9845942" cy="292608"/>
+            <a:off x="502920" y="256032"/>
+            <a:ext cx="9845942" cy="566928"/>
           </a:xfrm>
           <a:prstGeom prst="rect">
             <a:avLst/>
@@ -6001,14 +5965,14 @@
           <a:noFill/>
         </p:spPr>
         <p:txBody>
-          <a:bodyPr wrap="square" lIns="22000" rIns="22000" tIns="8000" bIns="8000" anchor="t">
+          <a:bodyPr wrap="square" lIns="18000" rIns="18000" tIns="4000" bIns="4000" anchor="ctr">
             <a:spAutoFit/>
           </a:bodyPr>
           <a:lstStyle/>
           <a:p>
             <a:pPr algn="l">
               <a:lnSpc>
-                <a:spcPct val="150000"/>
+                <a:spcPct val="115000"/>
               </a:lnSpc>
               <a:spcBef>
                 <a:spcPts val="0"/>
@@ -6018,52 +5982,16 @@
               </a:spcAft>
             </a:pPr>
             <a:r>
-              <a:rPr sz="1700" b="1">
+              <a:rPr sz="2800" b="1">
                 <a:solidFill>
                   <a:srgbClr val="C45C26"/>
                 </a:solidFill>
                 <a:latin typeface="Calibri"/>
               </a:rPr>
-              <a:t>WHO WE ARE</a:t>
-            </a:r>
-          </a:p>
-        </p:txBody>
-      </p:sp>
-      <p:sp>
-        <p:nvSpPr>
-          <p:cNvPr id="8" name="TextBox 7"/>
-          <p:cNvSpPr txBox="1"/>
-          <p:nvPr/>
-        </p:nvSpPr>
-        <p:spPr>
-          <a:xfrm>
-            <a:off x="502920" y="402336"/>
-            <a:ext cx="9845942" cy="530352"/>
-          </a:xfrm>
-          <a:prstGeom prst="rect">
-            <a:avLst/>
-          </a:prstGeom>
-          <a:noFill/>
-        </p:spPr>
-        <p:txBody>
-          <a:bodyPr wrap="square" lIns="22000" rIns="22000" tIns="8000" bIns="8000" anchor="t">
-            <a:spAutoFit/>
-          </a:bodyPr>
-          <a:lstStyle/>
-          <a:p>
-            <a:pPr algn="l">
-              <a:lnSpc>
-                <a:spcPct val="150000"/>
-              </a:lnSpc>
-              <a:spcBef>
-                <a:spcPts val="0"/>
-              </a:spcBef>
-              <a:spcAft>
-                <a:spcPts val="0"/>
-              </a:spcAft>
-            </a:pPr>
-            <a:r>
-              <a:rPr sz="3200" b="1">
+              <a:t>Who we are: </a:t>
+            </a:r>
+            <a:r>
+              <a:rPr sz="2800" b="1">
                 <a:solidFill>
                   <a:srgbClr val="0A1F2E"/>
                 </a:solidFill>
@@ -6076,14 +6004,14 @@
       </p:sp>
       <p:sp>
         <p:nvSpPr>
-          <p:cNvPr id="9" name="Rounded Rectangle 8"/>
+          <p:cNvPr id="8" name="Rounded Rectangle 7"/>
           <p:cNvSpPr/>
           <p:nvPr/>
         </p:nvSpPr>
         <p:spPr>
           <a:xfrm>
-            <a:off x="502920" y="1097280"/>
-            <a:ext cx="6537960" cy="4956048"/>
+            <a:off x="502920" y="960120"/>
+            <a:ext cx="6537960" cy="5093208"/>
           </a:xfrm>
           <a:prstGeom prst="roundRect">
             <a:avLst>
@@ -6124,13 +6052,13 @@
       </p:sp>
       <p:sp>
         <p:nvSpPr>
-          <p:cNvPr id="10" name="TextBox 9"/>
+          <p:cNvPr id="9" name="TextBox 8"/>
           <p:cNvSpPr txBox="1"/>
           <p:nvPr/>
         </p:nvSpPr>
         <p:spPr>
           <a:xfrm>
-            <a:off x="822960" y="1353312"/>
+            <a:off x="822960" y="1216152"/>
             <a:ext cx="5897880" cy="384048"/>
           </a:xfrm>
           <a:prstGeom prst="rect">
@@ -6169,13 +6097,13 @@
       </p:sp>
       <p:sp>
         <p:nvSpPr>
-          <p:cNvPr id="11" name="TextBox 10"/>
+          <p:cNvPr id="10" name="TextBox 9"/>
           <p:cNvSpPr txBox="1"/>
           <p:nvPr/>
         </p:nvSpPr>
         <p:spPr>
           <a:xfrm>
-            <a:off x="822960" y="1783080"/>
+            <a:off x="822960" y="1645920"/>
             <a:ext cx="5897880" cy="310896"/>
           </a:xfrm>
           <a:prstGeom prst="rect">
@@ -6214,14 +6142,14 @@
       </p:sp>
       <p:sp>
         <p:nvSpPr>
-          <p:cNvPr id="12" name="TextBox 11"/>
+          <p:cNvPr id="11" name="TextBox 10"/>
           <p:cNvSpPr txBox="1"/>
           <p:nvPr/>
         </p:nvSpPr>
         <p:spPr>
           <a:xfrm>
-            <a:off x="822960" y="2240280"/>
-            <a:ext cx="5897880" cy="3584448"/>
+            <a:off x="822960" y="2103120"/>
+            <a:ext cx="5897880" cy="3721608"/>
           </a:xfrm>
           <a:prstGeom prst="rect">
             <a:avLst/>
@@ -6347,7 +6275,7 @@
       </p:sp>
       <p:pic>
         <p:nvPicPr>
-          <p:cNvPr id="13" name="Picture 12" descr="facility_exterior_entrance_01.jpg"/>
+          <p:cNvPr id="12" name="Picture 11" descr="facility_exterior_entrance_01.jpg"/>
           <p:cNvPicPr>
             <a:picLocks noChangeAspect="1"/>
           </p:cNvPicPr>
@@ -6355,15 +6283,15 @@
         </p:nvPicPr>
         <p:blipFill>
           <a:blip r:embed="rId3"/>
-          <a:srcRect t="1120" b="1120"/>
+          <a:srcRect l="232" r="232"/>
           <a:stretch>
             <a:fillRect/>
           </a:stretch>
         </p:blipFill>
         <p:spPr>
           <a:xfrm>
-            <a:off x="7278624" y="1097280"/>
-            <a:ext cx="4410151" cy="2874507"/>
+            <a:off x="7278624" y="960120"/>
+            <a:ext cx="4410151" cy="2954060"/>
           </a:xfrm>
           <a:prstGeom prst="rect">
             <a:avLst/>
@@ -6372,14 +6300,14 @@
       </p:pic>
       <p:sp>
         <p:nvSpPr>
-          <p:cNvPr id="14" name="Rounded Rectangle 13"/>
+          <p:cNvPr id="13" name="Rounded Rectangle 12"/>
           <p:cNvSpPr/>
           <p:nvPr/>
         </p:nvSpPr>
         <p:spPr>
           <a:xfrm>
-            <a:off x="7278624" y="4099803"/>
-            <a:ext cx="4410151" cy="1953524"/>
+            <a:off x="7278624" y="4042196"/>
+            <a:ext cx="4410151" cy="2011131"/>
           </a:xfrm>
           <a:prstGeom prst="roundRect">
             <a:avLst>
@@ -6418,13 +6346,13 @@
       </p:sp>
       <p:sp>
         <p:nvSpPr>
-          <p:cNvPr id="15" name="TextBox 14"/>
+          <p:cNvPr id="14" name="TextBox 13"/>
           <p:cNvSpPr txBox="1"/>
           <p:nvPr/>
         </p:nvSpPr>
         <p:spPr>
           <a:xfrm>
-            <a:off x="7479792" y="4282683"/>
+            <a:off x="7479792" y="4225076"/>
             <a:ext cx="4007815" cy="329184"/>
           </a:xfrm>
           <a:prstGeom prst="rect">
@@ -6463,14 +6391,14 @@
       </p:sp>
       <p:sp>
         <p:nvSpPr>
-          <p:cNvPr id="16" name="TextBox 15"/>
+          <p:cNvPr id="15" name="TextBox 14"/>
           <p:cNvSpPr txBox="1"/>
           <p:nvPr/>
         </p:nvSpPr>
         <p:spPr>
           <a:xfrm>
-            <a:off x="7479792" y="4648443"/>
-            <a:ext cx="4007815" cy="1222004"/>
+            <a:off x="7479792" y="4590836"/>
+            <a:ext cx="4007815" cy="1279611"/>
           </a:xfrm>
           <a:prstGeom prst="rect">
             <a:avLst/>
@@ -6530,7 +6458,7 @@
       </p:sp>
       <p:sp>
         <p:nvSpPr>
-          <p:cNvPr id="17" name="Rectangle 16"/>
+          <p:cNvPr id="16" name="Rectangle 15"/>
           <p:cNvSpPr/>
           <p:nvPr/>
         </p:nvSpPr>
@@ -6574,7 +6502,7 @@
       </p:sp>
       <p:sp>
         <p:nvSpPr>
-          <p:cNvPr id="18" name="TextBox 17"/>
+          <p:cNvPr id="17" name="TextBox 16"/>
           <p:cNvSpPr txBox="1"/>
           <p:nvPr/>
         </p:nvSpPr>
@@ -6619,7 +6547,7 @@
       </p:sp>
       <p:sp>
         <p:nvSpPr>
-          <p:cNvPr id="19" name="TextBox 18"/>
+          <p:cNvPr id="18" name="TextBox 17"/>
           <p:cNvSpPr txBox="1"/>
           <p:nvPr/>
         </p:nvSpPr>
@@ -6895,8 +6823,62 @@
         </p:nvSpPr>
         <p:spPr>
           <a:xfrm>
-            <a:off x="502920" y="146304"/>
-            <a:ext cx="9845942" cy="292608"/>
+            <a:off x="502920" y="256032"/>
+            <a:ext cx="9845942" cy="566928"/>
+          </a:xfrm>
+          <a:prstGeom prst="rect">
+            <a:avLst/>
+          </a:prstGeom>
+          <a:noFill/>
+        </p:spPr>
+        <p:txBody>
+          <a:bodyPr wrap="square" lIns="18000" rIns="18000" tIns="4000" bIns="4000" anchor="ctr">
+            <a:spAutoFit/>
+          </a:bodyPr>
+          <a:lstStyle/>
+          <a:p>
+            <a:pPr algn="l">
+              <a:lnSpc>
+                <a:spcPct val="115000"/>
+              </a:lnSpc>
+              <a:spcBef>
+                <a:spcPts val="0"/>
+              </a:spcBef>
+              <a:spcAft>
+                <a:spcPts val="0"/>
+              </a:spcAft>
+            </a:pPr>
+            <a:r>
+              <a:rPr sz="2800" b="1">
+                <a:solidFill>
+                  <a:srgbClr val="C45C26"/>
+                </a:solidFill>
+                <a:latin typeface="Calibri"/>
+              </a:rPr>
+              <a:t>Operating model: </a:t>
+            </a:r>
+            <a:r>
+              <a:rPr sz="2800" b="1">
+                <a:solidFill>
+                  <a:srgbClr val="0A1F2E"/>
+                </a:solidFill>
+                <a:latin typeface="Calibri"/>
+              </a:rPr>
+              <a:t>FairBanks Community Reach</a:t>
+            </a:r>
+          </a:p>
+        </p:txBody>
+      </p:sp>
+      <p:sp>
+        <p:nvSpPr>
+          <p:cNvPr id="8" name="TextBox 7"/>
+          <p:cNvSpPr txBox="1"/>
+          <p:nvPr/>
+        </p:nvSpPr>
+        <p:spPr>
+          <a:xfrm>
+            <a:off x="502920" y="914400"/>
+            <a:ext cx="11185855" cy="384048"/>
           </a:xfrm>
           <a:prstGeom prst="rect">
             <a:avLst/>
@@ -6921,96 +6903,6 @@
               </a:spcAft>
             </a:pPr>
             <a:r>
-              <a:rPr sz="1700" b="1">
-                <a:solidFill>
-                  <a:srgbClr val="C45C26"/>
-                </a:solidFill>
-                <a:latin typeface="Calibri"/>
-              </a:rPr>
-              <a:t>OPERATING MODEL</a:t>
-            </a:r>
-          </a:p>
-        </p:txBody>
-      </p:sp>
-      <p:sp>
-        <p:nvSpPr>
-          <p:cNvPr id="8" name="TextBox 7"/>
-          <p:cNvSpPr txBox="1"/>
-          <p:nvPr/>
-        </p:nvSpPr>
-        <p:spPr>
-          <a:xfrm>
-            <a:off x="502920" y="402336"/>
-            <a:ext cx="9845942" cy="530352"/>
-          </a:xfrm>
-          <a:prstGeom prst="rect">
-            <a:avLst/>
-          </a:prstGeom>
-          <a:noFill/>
-        </p:spPr>
-        <p:txBody>
-          <a:bodyPr wrap="square" lIns="22000" rIns="22000" tIns="8000" bIns="8000" anchor="t">
-            <a:spAutoFit/>
-          </a:bodyPr>
-          <a:lstStyle/>
-          <a:p>
-            <a:pPr algn="l">
-              <a:lnSpc>
-                <a:spcPct val="150000"/>
-              </a:lnSpc>
-              <a:spcBef>
-                <a:spcPts val="0"/>
-              </a:spcBef>
-              <a:spcAft>
-                <a:spcPts val="0"/>
-              </a:spcAft>
-            </a:pPr>
-            <a:r>
-              <a:rPr sz="3200" b="1">
-                <a:solidFill>
-                  <a:srgbClr val="0A1F2E"/>
-                </a:solidFill>
-                <a:latin typeface="Calibri"/>
-              </a:rPr>
-              <a:t>FairBanks Community Reach</a:t>
-            </a:r>
-          </a:p>
-        </p:txBody>
-      </p:sp>
-      <p:sp>
-        <p:nvSpPr>
-          <p:cNvPr id="9" name="TextBox 8"/>
-          <p:cNvSpPr txBox="1"/>
-          <p:nvPr/>
-        </p:nvSpPr>
-        <p:spPr>
-          <a:xfrm>
-            <a:off x="502920" y="1005840"/>
-            <a:ext cx="11185855" cy="384048"/>
-          </a:xfrm>
-          <a:prstGeom prst="rect">
-            <a:avLst/>
-          </a:prstGeom>
-          <a:noFill/>
-        </p:spPr>
-        <p:txBody>
-          <a:bodyPr wrap="square" lIns="22000" rIns="22000" tIns="8000" bIns="8000" anchor="t">
-            <a:spAutoFit/>
-          </a:bodyPr>
-          <a:lstStyle/>
-          <a:p>
-            <a:pPr algn="l">
-              <a:lnSpc>
-                <a:spcPct val="150000"/>
-              </a:lnSpc>
-              <a:spcBef>
-                <a:spcPts val="0"/>
-              </a:spcBef>
-              <a:spcAft>
-                <a:spcPts val="0"/>
-              </a:spcAft>
-            </a:pPr>
-            <a:r>
               <a:rPr sz="2000" b="0">
                 <a:solidFill>
                   <a:srgbClr val="52636C"/>
@@ -7024,14 +6916,14 @@
       </p:sp>
       <p:sp>
         <p:nvSpPr>
-          <p:cNvPr id="10" name="Rounded Rectangle 9"/>
+          <p:cNvPr id="9" name="Rounded Rectangle 8"/>
           <p:cNvSpPr/>
           <p:nvPr/>
         </p:nvSpPr>
         <p:spPr>
           <a:xfrm>
-            <a:off x="502920" y="1444752"/>
-            <a:ext cx="5483199" cy="1426463"/>
+            <a:off x="502920" y="1298448"/>
+            <a:ext cx="5483199" cy="1475232"/>
           </a:xfrm>
           <a:prstGeom prst="roundRect">
             <a:avLst>
@@ -7072,14 +6964,14 @@
       </p:sp>
       <p:sp>
         <p:nvSpPr>
-          <p:cNvPr id="11" name="Rectangle 10"/>
+          <p:cNvPr id="10" name="Rectangle 9"/>
           <p:cNvSpPr/>
           <p:nvPr/>
         </p:nvSpPr>
         <p:spPr>
           <a:xfrm>
-            <a:off x="502920" y="1444752"/>
-            <a:ext cx="777240" cy="1426463"/>
+            <a:off x="502920" y="1298448"/>
+            <a:ext cx="777240" cy="1475232"/>
           </a:xfrm>
           <a:prstGeom prst="rect">
             <a:avLst/>
@@ -7116,14 +7008,14 @@
       </p:sp>
       <p:sp>
         <p:nvSpPr>
-          <p:cNvPr id="12" name="TextBox 11"/>
+          <p:cNvPr id="11" name="TextBox 10"/>
           <p:cNvSpPr txBox="1"/>
           <p:nvPr/>
         </p:nvSpPr>
         <p:spPr>
           <a:xfrm>
-            <a:off x="502920" y="1444752"/>
-            <a:ext cx="777240" cy="1426463"/>
+            <a:off x="502920" y="1298448"/>
+            <a:ext cx="777240" cy="1475232"/>
           </a:xfrm>
           <a:prstGeom prst="rect">
             <a:avLst/>
@@ -7161,13 +7053,13 @@
       </p:sp>
       <p:sp>
         <p:nvSpPr>
-          <p:cNvPr id="13" name="TextBox 12"/>
+          <p:cNvPr id="12" name="TextBox 11"/>
           <p:cNvSpPr txBox="1"/>
           <p:nvPr/>
         </p:nvSpPr>
         <p:spPr>
           <a:xfrm>
-            <a:off x="1463040" y="1682496"/>
+            <a:off x="1463040" y="1536192"/>
             <a:ext cx="4340199" cy="438912"/>
           </a:xfrm>
           <a:prstGeom prst="rect">
@@ -7206,14 +7098,14 @@
       </p:sp>
       <p:sp>
         <p:nvSpPr>
-          <p:cNvPr id="14" name="TextBox 13"/>
+          <p:cNvPr id="13" name="TextBox 12"/>
           <p:cNvSpPr txBox="1"/>
           <p:nvPr/>
         </p:nvSpPr>
         <p:spPr>
           <a:xfrm>
-            <a:off x="1463040" y="2176272"/>
-            <a:ext cx="4340199" cy="512063"/>
+            <a:off x="1463040" y="2029967"/>
+            <a:ext cx="4340199" cy="560832"/>
           </a:xfrm>
           <a:prstGeom prst="rect">
             <a:avLst/>
@@ -7251,14 +7143,14 @@
       </p:sp>
       <p:sp>
         <p:nvSpPr>
-          <p:cNvPr id="15" name="Rounded Rectangle 14"/>
+          <p:cNvPr id="14" name="Rounded Rectangle 13"/>
           <p:cNvSpPr/>
           <p:nvPr/>
         </p:nvSpPr>
         <p:spPr>
           <a:xfrm>
-            <a:off x="6205575" y="1444752"/>
-            <a:ext cx="5483199" cy="1426463"/>
+            <a:off x="6205575" y="1298448"/>
+            <a:ext cx="5483199" cy="1475232"/>
           </a:xfrm>
           <a:prstGeom prst="roundRect">
             <a:avLst>
@@ -7299,14 +7191,14 @@
       </p:sp>
       <p:sp>
         <p:nvSpPr>
-          <p:cNvPr id="16" name="Rectangle 15"/>
+          <p:cNvPr id="15" name="Rectangle 14"/>
           <p:cNvSpPr/>
           <p:nvPr/>
         </p:nvSpPr>
         <p:spPr>
           <a:xfrm>
-            <a:off x="6205575" y="1444752"/>
-            <a:ext cx="777240" cy="1426463"/>
+            <a:off x="6205575" y="1298448"/>
+            <a:ext cx="777240" cy="1475232"/>
           </a:xfrm>
           <a:prstGeom prst="rect">
             <a:avLst/>
@@ -7343,14 +7235,14 @@
       </p:sp>
       <p:sp>
         <p:nvSpPr>
-          <p:cNvPr id="17" name="TextBox 16"/>
+          <p:cNvPr id="16" name="TextBox 15"/>
           <p:cNvSpPr txBox="1"/>
           <p:nvPr/>
         </p:nvSpPr>
         <p:spPr>
           <a:xfrm>
-            <a:off x="6205575" y="1444752"/>
-            <a:ext cx="777240" cy="1426463"/>
+            <a:off x="6205575" y="1298448"/>
+            <a:ext cx="777240" cy="1475232"/>
           </a:xfrm>
           <a:prstGeom prst="rect">
             <a:avLst/>
@@ -7388,13 +7280,13 @@
       </p:sp>
       <p:sp>
         <p:nvSpPr>
-          <p:cNvPr id="18" name="TextBox 17"/>
+          <p:cNvPr id="17" name="TextBox 16"/>
           <p:cNvSpPr txBox="1"/>
           <p:nvPr/>
         </p:nvSpPr>
         <p:spPr>
           <a:xfrm>
-            <a:off x="7165695" y="1682496"/>
+            <a:off x="7165695" y="1536192"/>
             <a:ext cx="4340199" cy="438912"/>
           </a:xfrm>
           <a:prstGeom prst="rect">
@@ -7433,14 +7325,14 @@
       </p:sp>
       <p:sp>
         <p:nvSpPr>
-          <p:cNvPr id="19" name="TextBox 18"/>
+          <p:cNvPr id="18" name="TextBox 17"/>
           <p:cNvSpPr txBox="1"/>
           <p:nvPr/>
         </p:nvSpPr>
         <p:spPr>
           <a:xfrm>
-            <a:off x="7165695" y="2176272"/>
-            <a:ext cx="4340199" cy="512063"/>
+            <a:off x="7165695" y="2029967"/>
+            <a:ext cx="4340199" cy="560832"/>
           </a:xfrm>
           <a:prstGeom prst="rect">
             <a:avLst/>
@@ -7478,14 +7370,14 @@
       </p:sp>
       <p:sp>
         <p:nvSpPr>
-          <p:cNvPr id="20" name="Rounded Rectangle 19"/>
+          <p:cNvPr id="19" name="Rounded Rectangle 18"/>
           <p:cNvSpPr/>
           <p:nvPr/>
         </p:nvSpPr>
         <p:spPr>
           <a:xfrm>
-            <a:off x="502920" y="3035808"/>
-            <a:ext cx="5483199" cy="1426463"/>
+            <a:off x="502920" y="2938271"/>
+            <a:ext cx="5483199" cy="1475232"/>
           </a:xfrm>
           <a:prstGeom prst="roundRect">
             <a:avLst>
@@ -7526,14 +7418,14 @@
       </p:sp>
       <p:sp>
         <p:nvSpPr>
-          <p:cNvPr id="21" name="Rectangle 20"/>
+          <p:cNvPr id="20" name="Rectangle 19"/>
           <p:cNvSpPr/>
           <p:nvPr/>
         </p:nvSpPr>
         <p:spPr>
           <a:xfrm>
-            <a:off x="502920" y="3035808"/>
-            <a:ext cx="777240" cy="1426463"/>
+            <a:off x="502920" y="2938271"/>
+            <a:ext cx="777240" cy="1475232"/>
           </a:xfrm>
           <a:prstGeom prst="rect">
             <a:avLst/>
@@ -7570,14 +7462,14 @@
       </p:sp>
       <p:sp>
         <p:nvSpPr>
-          <p:cNvPr id="22" name="TextBox 21"/>
+          <p:cNvPr id="21" name="TextBox 20"/>
           <p:cNvSpPr txBox="1"/>
           <p:nvPr/>
         </p:nvSpPr>
         <p:spPr>
           <a:xfrm>
-            <a:off x="502920" y="3035808"/>
-            <a:ext cx="777240" cy="1426463"/>
+            <a:off x="502920" y="2938271"/>
+            <a:ext cx="777240" cy="1475232"/>
           </a:xfrm>
           <a:prstGeom prst="rect">
             <a:avLst/>
@@ -7615,13 +7507,13 @@
       </p:sp>
       <p:sp>
         <p:nvSpPr>
-          <p:cNvPr id="23" name="TextBox 22"/>
+          <p:cNvPr id="22" name="TextBox 21"/>
           <p:cNvSpPr txBox="1"/>
           <p:nvPr/>
         </p:nvSpPr>
         <p:spPr>
           <a:xfrm>
-            <a:off x="1463040" y="3273552"/>
+            <a:off x="1463040" y="3176015"/>
             <a:ext cx="4340199" cy="438912"/>
           </a:xfrm>
           <a:prstGeom prst="rect">
@@ -7660,14 +7552,14 @@
       </p:sp>
       <p:sp>
         <p:nvSpPr>
-          <p:cNvPr id="24" name="TextBox 23"/>
+          <p:cNvPr id="23" name="TextBox 22"/>
           <p:cNvSpPr txBox="1"/>
           <p:nvPr/>
         </p:nvSpPr>
         <p:spPr>
           <a:xfrm>
-            <a:off x="1463040" y="3767328"/>
-            <a:ext cx="4340199" cy="512063"/>
+            <a:off x="1463040" y="3669791"/>
+            <a:ext cx="4340199" cy="560832"/>
           </a:xfrm>
           <a:prstGeom prst="rect">
             <a:avLst/>
@@ -7705,14 +7597,14 @@
       </p:sp>
       <p:sp>
         <p:nvSpPr>
-          <p:cNvPr id="25" name="Rounded Rectangle 24"/>
+          <p:cNvPr id="24" name="Rounded Rectangle 23"/>
           <p:cNvSpPr/>
           <p:nvPr/>
         </p:nvSpPr>
         <p:spPr>
           <a:xfrm>
-            <a:off x="6205575" y="3035808"/>
-            <a:ext cx="5483199" cy="1426463"/>
+            <a:off x="6205575" y="2938271"/>
+            <a:ext cx="5483199" cy="1475232"/>
           </a:xfrm>
           <a:prstGeom prst="roundRect">
             <a:avLst>
@@ -7753,14 +7645,14 @@
       </p:sp>
       <p:sp>
         <p:nvSpPr>
-          <p:cNvPr id="26" name="Rectangle 25"/>
+          <p:cNvPr id="25" name="Rectangle 24"/>
           <p:cNvSpPr/>
           <p:nvPr/>
         </p:nvSpPr>
         <p:spPr>
           <a:xfrm>
-            <a:off x="6205575" y="3035808"/>
-            <a:ext cx="777240" cy="1426463"/>
+            <a:off x="6205575" y="2938271"/>
+            <a:ext cx="777240" cy="1475232"/>
           </a:xfrm>
           <a:prstGeom prst="rect">
             <a:avLst/>
@@ -7797,14 +7689,14 @@
       </p:sp>
       <p:sp>
         <p:nvSpPr>
-          <p:cNvPr id="27" name="TextBox 26"/>
+          <p:cNvPr id="26" name="TextBox 25"/>
           <p:cNvSpPr txBox="1"/>
           <p:nvPr/>
         </p:nvSpPr>
         <p:spPr>
           <a:xfrm>
-            <a:off x="6205575" y="3035808"/>
-            <a:ext cx="777240" cy="1426463"/>
+            <a:off x="6205575" y="2938271"/>
+            <a:ext cx="777240" cy="1475232"/>
           </a:xfrm>
           <a:prstGeom prst="rect">
             <a:avLst/>
@@ -7842,13 +7734,13 @@
       </p:sp>
       <p:sp>
         <p:nvSpPr>
-          <p:cNvPr id="28" name="TextBox 27"/>
+          <p:cNvPr id="27" name="TextBox 26"/>
           <p:cNvSpPr txBox="1"/>
           <p:nvPr/>
         </p:nvSpPr>
         <p:spPr>
           <a:xfrm>
-            <a:off x="7165695" y="3273552"/>
+            <a:off x="7165695" y="3176015"/>
             <a:ext cx="4340199" cy="438912"/>
           </a:xfrm>
           <a:prstGeom prst="rect">
@@ -7887,14 +7779,14 @@
       </p:sp>
       <p:sp>
         <p:nvSpPr>
-          <p:cNvPr id="29" name="TextBox 28"/>
+          <p:cNvPr id="28" name="TextBox 27"/>
           <p:cNvSpPr txBox="1"/>
           <p:nvPr/>
         </p:nvSpPr>
         <p:spPr>
           <a:xfrm>
-            <a:off x="7165695" y="3767328"/>
-            <a:ext cx="4340199" cy="512063"/>
+            <a:off x="7165695" y="3669791"/>
+            <a:ext cx="4340199" cy="560832"/>
           </a:xfrm>
           <a:prstGeom prst="rect">
             <a:avLst/>
@@ -7932,14 +7824,14 @@
       </p:sp>
       <p:sp>
         <p:nvSpPr>
-          <p:cNvPr id="30" name="Rounded Rectangle 29"/>
+          <p:cNvPr id="29" name="Rounded Rectangle 28"/>
           <p:cNvSpPr/>
           <p:nvPr/>
         </p:nvSpPr>
         <p:spPr>
           <a:xfrm>
-            <a:off x="502920" y="4626864"/>
-            <a:ext cx="5483199" cy="1426463"/>
+            <a:off x="502920" y="4578095"/>
+            <a:ext cx="5483199" cy="1475232"/>
           </a:xfrm>
           <a:prstGeom prst="roundRect">
             <a:avLst>
@@ -7980,14 +7872,14 @@
       </p:sp>
       <p:sp>
         <p:nvSpPr>
-          <p:cNvPr id="31" name="Rectangle 30"/>
+          <p:cNvPr id="30" name="Rectangle 29"/>
           <p:cNvSpPr/>
           <p:nvPr/>
         </p:nvSpPr>
         <p:spPr>
           <a:xfrm>
-            <a:off x="502920" y="4626864"/>
-            <a:ext cx="777240" cy="1426463"/>
+            <a:off x="502920" y="4578095"/>
+            <a:ext cx="777240" cy="1475232"/>
           </a:xfrm>
           <a:prstGeom prst="rect">
             <a:avLst/>
@@ -8024,14 +7916,14 @@
       </p:sp>
       <p:sp>
         <p:nvSpPr>
-          <p:cNvPr id="32" name="TextBox 31"/>
+          <p:cNvPr id="31" name="TextBox 30"/>
           <p:cNvSpPr txBox="1"/>
           <p:nvPr/>
         </p:nvSpPr>
         <p:spPr>
           <a:xfrm>
-            <a:off x="502920" y="4626864"/>
-            <a:ext cx="777240" cy="1426463"/>
+            <a:off x="502920" y="4578095"/>
+            <a:ext cx="777240" cy="1475232"/>
           </a:xfrm>
           <a:prstGeom prst="rect">
             <a:avLst/>
@@ -8069,13 +7961,13 @@
       </p:sp>
       <p:sp>
         <p:nvSpPr>
-          <p:cNvPr id="33" name="TextBox 32"/>
+          <p:cNvPr id="32" name="TextBox 31"/>
           <p:cNvSpPr txBox="1"/>
           <p:nvPr/>
         </p:nvSpPr>
         <p:spPr>
           <a:xfrm>
-            <a:off x="1463040" y="4864607"/>
+            <a:off x="1463040" y="4815839"/>
             <a:ext cx="4340199" cy="438912"/>
           </a:xfrm>
           <a:prstGeom prst="rect">
@@ -8114,14 +8006,14 @@
       </p:sp>
       <p:sp>
         <p:nvSpPr>
-          <p:cNvPr id="34" name="TextBox 33"/>
+          <p:cNvPr id="33" name="TextBox 32"/>
           <p:cNvSpPr txBox="1"/>
           <p:nvPr/>
         </p:nvSpPr>
         <p:spPr>
           <a:xfrm>
-            <a:off x="1463040" y="5358383"/>
-            <a:ext cx="4340199" cy="512063"/>
+            <a:off x="1463040" y="5309615"/>
+            <a:ext cx="4340199" cy="560832"/>
           </a:xfrm>
           <a:prstGeom prst="rect">
             <a:avLst/>
@@ -8159,14 +8051,14 @@
       </p:sp>
       <p:sp>
         <p:nvSpPr>
-          <p:cNvPr id="35" name="Rounded Rectangle 34"/>
+          <p:cNvPr id="34" name="Rounded Rectangle 33"/>
           <p:cNvSpPr/>
           <p:nvPr/>
         </p:nvSpPr>
         <p:spPr>
           <a:xfrm>
-            <a:off x="6205575" y="4626864"/>
-            <a:ext cx="5483199" cy="1426463"/>
+            <a:off x="6205575" y="4578095"/>
+            <a:ext cx="5483199" cy="1475232"/>
           </a:xfrm>
           <a:prstGeom prst="roundRect">
             <a:avLst>
@@ -8207,14 +8099,14 @@
       </p:sp>
       <p:sp>
         <p:nvSpPr>
-          <p:cNvPr id="36" name="Rectangle 35"/>
+          <p:cNvPr id="35" name="Rectangle 34"/>
           <p:cNvSpPr/>
           <p:nvPr/>
         </p:nvSpPr>
         <p:spPr>
           <a:xfrm>
-            <a:off x="6205575" y="4626864"/>
-            <a:ext cx="777240" cy="1426463"/>
+            <a:off x="6205575" y="4578095"/>
+            <a:ext cx="777240" cy="1475232"/>
           </a:xfrm>
           <a:prstGeom prst="rect">
             <a:avLst/>
@@ -8251,14 +8143,14 @@
       </p:sp>
       <p:sp>
         <p:nvSpPr>
-          <p:cNvPr id="37" name="TextBox 36"/>
+          <p:cNvPr id="36" name="TextBox 35"/>
           <p:cNvSpPr txBox="1"/>
           <p:nvPr/>
         </p:nvSpPr>
         <p:spPr>
           <a:xfrm>
-            <a:off x="6205575" y="4626864"/>
-            <a:ext cx="777240" cy="1426463"/>
+            <a:off x="6205575" y="4578095"/>
+            <a:ext cx="777240" cy="1475232"/>
           </a:xfrm>
           <a:prstGeom prst="rect">
             <a:avLst/>
@@ -8296,13 +8188,13 @@
       </p:sp>
       <p:sp>
         <p:nvSpPr>
-          <p:cNvPr id="38" name="TextBox 37"/>
+          <p:cNvPr id="37" name="TextBox 36"/>
           <p:cNvSpPr txBox="1"/>
           <p:nvPr/>
         </p:nvSpPr>
         <p:spPr>
           <a:xfrm>
-            <a:off x="7165695" y="4864607"/>
+            <a:off x="7165695" y="4815839"/>
             <a:ext cx="4340199" cy="438912"/>
           </a:xfrm>
           <a:prstGeom prst="rect">
@@ -8341,14 +8233,14 @@
       </p:sp>
       <p:sp>
         <p:nvSpPr>
-          <p:cNvPr id="39" name="TextBox 38"/>
+          <p:cNvPr id="38" name="TextBox 37"/>
           <p:cNvSpPr txBox="1"/>
           <p:nvPr/>
         </p:nvSpPr>
         <p:spPr>
           <a:xfrm>
-            <a:off x="7165695" y="5358383"/>
-            <a:ext cx="4340199" cy="512063"/>
+            <a:off x="7165695" y="5309615"/>
+            <a:ext cx="4340199" cy="560832"/>
           </a:xfrm>
           <a:prstGeom prst="rect">
             <a:avLst/>
@@ -8386,7 +8278,7 @@
       </p:sp>
       <p:sp>
         <p:nvSpPr>
-          <p:cNvPr id="40" name="Rectangle 39"/>
+          <p:cNvPr id="39" name="Rectangle 38"/>
           <p:cNvSpPr/>
           <p:nvPr/>
         </p:nvSpPr>
@@ -8430,7 +8322,7 @@
       </p:sp>
       <p:sp>
         <p:nvSpPr>
-          <p:cNvPr id="41" name="TextBox 40"/>
+          <p:cNvPr id="40" name="TextBox 39"/>
           <p:cNvSpPr txBox="1"/>
           <p:nvPr/>
         </p:nvSpPr>
@@ -8475,7 +8367,7 @@
       </p:sp>
       <p:sp>
         <p:nvSpPr>
-          <p:cNvPr id="42" name="TextBox 41"/>
+          <p:cNvPr id="41" name="TextBox 40"/>
           <p:cNvSpPr txBox="1"/>
           <p:nvPr/>
         </p:nvSpPr>
@@ -8796,8 +8688,8 @@
         </p:nvSpPr>
         <p:spPr>
           <a:xfrm>
-            <a:off x="502920" y="1097280"/>
-            <a:ext cx="5369210" cy="4956048"/>
+            <a:off x="502920" y="960120"/>
+            <a:ext cx="5369210" cy="5093208"/>
           </a:xfrm>
           <a:prstGeom prst="roundRect">
             <a:avLst>
@@ -8842,7 +8734,7 @@
         </p:nvSpPr>
         <p:spPr>
           <a:xfrm>
-            <a:off x="822960" y="1353312"/>
+            <a:off x="822960" y="1216152"/>
             <a:ext cx="4729130" cy="347472"/>
           </a:xfrm>
           <a:prstGeom prst="rect">
@@ -8887,7 +8779,7 @@
         </p:nvSpPr>
         <p:spPr>
           <a:xfrm>
-            <a:off x="822960" y="1755648"/>
+            <a:off x="822960" y="1618488"/>
             <a:ext cx="4729130" cy="822960"/>
           </a:xfrm>
           <a:prstGeom prst="rect">
@@ -8932,7 +8824,7 @@
         </p:nvSpPr>
         <p:spPr>
           <a:xfrm>
-            <a:off x="822960" y="2743200"/>
+            <a:off x="822960" y="2606040"/>
             <a:ext cx="4729130" cy="2194560"/>
           </a:xfrm>
           <a:prstGeom prst="rect">
@@ -9023,15 +8915,15 @@
         </p:nvPicPr>
         <p:blipFill>
           <a:blip r:embed="rId3"/>
-          <a:srcRect t="13475" b="13475"/>
+          <a:srcRect t="12464" b="12464"/>
           <a:stretch>
             <a:fillRect/>
           </a:stretch>
         </p:blipFill>
         <p:spPr>
           <a:xfrm>
-            <a:off x="6091586" y="1097280"/>
-            <a:ext cx="5597188" cy="2725826"/>
+            <a:off x="6091586" y="960120"/>
+            <a:ext cx="5597188" cy="2801264"/>
           </a:xfrm>
           <a:prstGeom prst="rect">
             <a:avLst/>
@@ -9046,8 +8938,8 @@
         </p:nvSpPr>
         <p:spPr>
           <a:xfrm>
-            <a:off x="6091586" y="3969410"/>
-            <a:ext cx="2734586" cy="621487"/>
+            <a:off x="6091586" y="3907688"/>
+            <a:ext cx="2734586" cy="642061"/>
           </a:xfrm>
           <a:prstGeom prst="roundRect">
             <a:avLst>
@@ -9094,8 +8986,8 @@
         </p:nvSpPr>
         <p:spPr>
           <a:xfrm>
-            <a:off x="6201314" y="4042562"/>
-            <a:ext cx="2515130" cy="475183"/>
+            <a:off x="6201314" y="3980840"/>
+            <a:ext cx="2515130" cy="495757"/>
           </a:xfrm>
           <a:prstGeom prst="rect">
             <a:avLst/>
@@ -9139,8 +9031,8 @@
         </p:nvSpPr>
         <p:spPr>
           <a:xfrm>
-            <a:off x="8954188" y="3969410"/>
-            <a:ext cx="2734586" cy="621487"/>
+            <a:off x="8954188" y="3907688"/>
+            <a:ext cx="2734586" cy="642061"/>
           </a:xfrm>
           <a:prstGeom prst="roundRect">
             <a:avLst>
@@ -9187,8 +9079,8 @@
         </p:nvSpPr>
         <p:spPr>
           <a:xfrm>
-            <a:off x="9063916" y="4042562"/>
-            <a:ext cx="2515130" cy="475183"/>
+            <a:off x="9063916" y="3980840"/>
+            <a:ext cx="2515130" cy="495757"/>
           </a:xfrm>
           <a:prstGeom prst="rect">
             <a:avLst/>
@@ -9232,8 +9124,8 @@
         </p:nvSpPr>
         <p:spPr>
           <a:xfrm>
-            <a:off x="6091586" y="4700625"/>
-            <a:ext cx="2734586" cy="621487"/>
+            <a:off x="6091586" y="4659477"/>
+            <a:ext cx="2734586" cy="642061"/>
           </a:xfrm>
           <a:prstGeom prst="roundRect">
             <a:avLst>
@@ -9280,8 +9172,8 @@
         </p:nvSpPr>
         <p:spPr>
           <a:xfrm>
-            <a:off x="6201314" y="4773777"/>
-            <a:ext cx="2515130" cy="475183"/>
+            <a:off x="6201314" y="4732629"/>
+            <a:ext cx="2515130" cy="495757"/>
           </a:xfrm>
           <a:prstGeom prst="rect">
             <a:avLst/>
@@ -9325,8 +9217,8 @@
         </p:nvSpPr>
         <p:spPr>
           <a:xfrm>
-            <a:off x="8954188" y="4700625"/>
-            <a:ext cx="2734586" cy="621487"/>
+            <a:off x="8954188" y="4659477"/>
+            <a:ext cx="2734586" cy="642061"/>
           </a:xfrm>
           <a:prstGeom prst="roundRect">
             <a:avLst>
@@ -9373,8 +9265,8 @@
         </p:nvSpPr>
         <p:spPr>
           <a:xfrm>
-            <a:off x="9063916" y="4773777"/>
-            <a:ext cx="2515130" cy="475183"/>
+            <a:off x="9063916" y="4732629"/>
+            <a:ext cx="2515130" cy="495757"/>
           </a:xfrm>
           <a:prstGeom prst="rect">
             <a:avLst/>
@@ -9418,8 +9310,8 @@
         </p:nvSpPr>
         <p:spPr>
           <a:xfrm>
-            <a:off x="6091586" y="5431840"/>
-            <a:ext cx="2734586" cy="621487"/>
+            <a:off x="6091586" y="5411266"/>
+            <a:ext cx="2734586" cy="642061"/>
           </a:xfrm>
           <a:prstGeom prst="roundRect">
             <a:avLst>
@@ -9466,8 +9358,8 @@
         </p:nvSpPr>
         <p:spPr>
           <a:xfrm>
-            <a:off x="6201314" y="5504992"/>
-            <a:ext cx="2515130" cy="475183"/>
+            <a:off x="6201314" y="5484418"/>
+            <a:ext cx="2515130" cy="495757"/>
           </a:xfrm>
           <a:prstGeom prst="rect">
             <a:avLst/>
@@ -9511,8 +9403,8 @@
         </p:nvSpPr>
         <p:spPr>
           <a:xfrm>
-            <a:off x="8954188" y="5431840"/>
-            <a:ext cx="2734586" cy="621487"/>
+            <a:off x="8954188" y="5411266"/>
+            <a:ext cx="2734586" cy="642061"/>
           </a:xfrm>
           <a:prstGeom prst="roundRect">
             <a:avLst>
@@ -9559,8 +9451,8 @@
         </p:nvSpPr>
         <p:spPr>
           <a:xfrm>
-            <a:off x="9063916" y="5504992"/>
-            <a:ext cx="2515130" cy="475183"/>
+            <a:off x="9063916" y="5484418"/>
+            <a:ext cx="2515130" cy="495757"/>
           </a:xfrm>
           <a:prstGeom prst="rect">
             <a:avLst/>
@@ -9963,8 +9855,62 @@
         </p:nvSpPr>
         <p:spPr>
           <a:xfrm>
-            <a:off x="502920" y="146304"/>
-            <a:ext cx="9845942" cy="292608"/>
+            <a:off x="502920" y="256032"/>
+            <a:ext cx="9845942" cy="566928"/>
+          </a:xfrm>
+          <a:prstGeom prst="rect">
+            <a:avLst/>
+          </a:prstGeom>
+          <a:noFill/>
+        </p:spPr>
+        <p:txBody>
+          <a:bodyPr wrap="square" lIns="18000" rIns="18000" tIns="4000" bIns="4000" anchor="ctr">
+            <a:spAutoFit/>
+          </a:bodyPr>
+          <a:lstStyle/>
+          <a:p>
+            <a:pPr algn="l">
+              <a:lnSpc>
+                <a:spcPct val="115000"/>
+              </a:lnSpc>
+              <a:spcBef>
+                <a:spcPts val="0"/>
+              </a:spcBef>
+              <a:spcAft>
+                <a:spcPts val="0"/>
+              </a:spcAft>
+            </a:pPr>
+            <a:r>
+              <a:rPr sz="2800" b="1">
+                <a:solidFill>
+                  <a:srgbClr val="C45C26"/>
+                </a:solidFill>
+                <a:latin typeface="Calibri"/>
+              </a:rPr>
+              <a:t>Fit with MUST: </a:t>
+            </a:r>
+            <a:r>
+              <a:rPr sz="2800" b="1">
+                <a:solidFill>
+                  <a:srgbClr val="0A1F2E"/>
+                </a:solidFill>
+                <a:latin typeface="Calibri"/>
+              </a:rPr>
+              <a:t>Why MUST is a strong partner</a:t>
+            </a:r>
+          </a:p>
+        </p:txBody>
+      </p:sp>
+      <p:sp>
+        <p:nvSpPr>
+          <p:cNvPr id="8" name="TextBox 7"/>
+          <p:cNvSpPr txBox="1"/>
+          <p:nvPr/>
+        </p:nvSpPr>
+        <p:spPr>
+          <a:xfrm>
+            <a:off x="502920" y="914400"/>
+            <a:ext cx="11185855" cy="384048"/>
           </a:xfrm>
           <a:prstGeom prst="rect">
             <a:avLst/>
@@ -9989,96 +9935,6 @@
               </a:spcAft>
             </a:pPr>
             <a:r>
-              <a:rPr sz="1700" b="1">
-                <a:solidFill>
-                  <a:srgbClr val="C45C26"/>
-                </a:solidFill>
-                <a:latin typeface="Calibri"/>
-              </a:rPr>
-              <a:t>FIT WITH MUST</a:t>
-            </a:r>
-          </a:p>
-        </p:txBody>
-      </p:sp>
-      <p:sp>
-        <p:nvSpPr>
-          <p:cNvPr id="8" name="TextBox 7"/>
-          <p:cNvSpPr txBox="1"/>
-          <p:nvPr/>
-        </p:nvSpPr>
-        <p:spPr>
-          <a:xfrm>
-            <a:off x="502920" y="402336"/>
-            <a:ext cx="9845942" cy="530352"/>
-          </a:xfrm>
-          <a:prstGeom prst="rect">
-            <a:avLst/>
-          </a:prstGeom>
-          <a:noFill/>
-        </p:spPr>
-        <p:txBody>
-          <a:bodyPr wrap="square" lIns="22000" rIns="22000" tIns="8000" bIns="8000" anchor="t">
-            <a:spAutoFit/>
-          </a:bodyPr>
-          <a:lstStyle/>
-          <a:p>
-            <a:pPr algn="l">
-              <a:lnSpc>
-                <a:spcPct val="150000"/>
-              </a:lnSpc>
-              <a:spcBef>
-                <a:spcPts val="0"/>
-              </a:spcBef>
-              <a:spcAft>
-                <a:spcPts val="0"/>
-              </a:spcAft>
-            </a:pPr>
-            <a:r>
-              <a:rPr sz="3200" b="1">
-                <a:solidFill>
-                  <a:srgbClr val="0A1F2E"/>
-                </a:solidFill>
-                <a:latin typeface="Calibri"/>
-              </a:rPr>
-              <a:t>Why MUST is a strong partner</a:t>
-            </a:r>
-          </a:p>
-        </p:txBody>
-      </p:sp>
-      <p:sp>
-        <p:nvSpPr>
-          <p:cNvPr id="9" name="TextBox 8"/>
-          <p:cNvSpPr txBox="1"/>
-          <p:nvPr/>
-        </p:nvSpPr>
-        <p:spPr>
-          <a:xfrm>
-            <a:off x="502920" y="1005840"/>
-            <a:ext cx="11185855" cy="384048"/>
-          </a:xfrm>
-          <a:prstGeom prst="rect">
-            <a:avLst/>
-          </a:prstGeom>
-          <a:noFill/>
-        </p:spPr>
-        <p:txBody>
-          <a:bodyPr wrap="square" lIns="22000" rIns="22000" tIns="8000" bIns="8000" anchor="t">
-            <a:spAutoFit/>
-          </a:bodyPr>
-          <a:lstStyle/>
-          <a:p>
-            <a:pPr algn="l">
-              <a:lnSpc>
-                <a:spcPct val="150000"/>
-              </a:lnSpc>
-              <a:spcBef>
-                <a:spcPts val="0"/>
-              </a:spcBef>
-              <a:spcAft>
-                <a:spcPts val="0"/>
-              </a:spcAft>
-            </a:pPr>
-            <a:r>
               <a:rPr sz="2000" b="0">
                 <a:solidFill>
                   <a:srgbClr val="52636C"/>
@@ -10092,14 +9948,14 @@
       </p:sp>
       <p:sp>
         <p:nvSpPr>
-          <p:cNvPr id="10" name="Rounded Rectangle 9"/>
+          <p:cNvPr id="9" name="Rounded Rectangle 8"/>
           <p:cNvSpPr/>
           <p:nvPr/>
         </p:nvSpPr>
         <p:spPr>
           <a:xfrm>
-            <a:off x="502920" y="1444752"/>
-            <a:ext cx="5510631" cy="2221992"/>
+            <a:off x="502920" y="1298448"/>
+            <a:ext cx="5510631" cy="2295144"/>
           </a:xfrm>
           <a:prstGeom prst="roundRect">
             <a:avLst>
@@ -10140,14 +9996,14 @@
       </p:sp>
       <p:sp>
         <p:nvSpPr>
-          <p:cNvPr id="11" name="Rectangle 10"/>
+          <p:cNvPr id="10" name="Rectangle 9"/>
           <p:cNvSpPr/>
           <p:nvPr/>
         </p:nvSpPr>
         <p:spPr>
           <a:xfrm>
-            <a:off x="667512" y="1645920"/>
-            <a:ext cx="91440" cy="1819656"/>
+            <a:off x="667512" y="1499616"/>
+            <a:ext cx="91440" cy="1892808"/>
           </a:xfrm>
           <a:prstGeom prst="rect">
             <a:avLst/>
@@ -10184,13 +10040,13 @@
       </p:sp>
       <p:sp>
         <p:nvSpPr>
-          <p:cNvPr id="12" name="TextBox 11"/>
+          <p:cNvPr id="11" name="TextBox 10"/>
           <p:cNvSpPr txBox="1"/>
           <p:nvPr/>
         </p:nvSpPr>
         <p:spPr>
           <a:xfrm>
-            <a:off x="914400" y="1700784"/>
+            <a:off x="914400" y="1554480"/>
             <a:ext cx="4870551" cy="502920"/>
           </a:xfrm>
           <a:prstGeom prst="rect">
@@ -10229,14 +10085,14 @@
       </p:sp>
       <p:sp>
         <p:nvSpPr>
-          <p:cNvPr id="13" name="TextBox 12"/>
+          <p:cNvPr id="12" name="TextBox 11"/>
           <p:cNvSpPr txBox="1"/>
           <p:nvPr/>
         </p:nvSpPr>
         <p:spPr>
           <a:xfrm>
-            <a:off x="914400" y="2313432"/>
-            <a:ext cx="4870551" cy="1078992"/>
+            <a:off x="914400" y="2167128"/>
+            <a:ext cx="4870551" cy="1152144"/>
           </a:xfrm>
           <a:prstGeom prst="rect">
             <a:avLst/>
@@ -10274,14 +10130,14 @@
       </p:sp>
       <p:sp>
         <p:nvSpPr>
-          <p:cNvPr id="14" name="Rounded Rectangle 13"/>
+          <p:cNvPr id="13" name="Rounded Rectangle 12"/>
           <p:cNvSpPr/>
           <p:nvPr/>
         </p:nvSpPr>
         <p:spPr>
           <a:xfrm>
-            <a:off x="6178143" y="1444752"/>
-            <a:ext cx="5510631" cy="2221992"/>
+            <a:off x="6178143" y="1298448"/>
+            <a:ext cx="5510631" cy="2295144"/>
           </a:xfrm>
           <a:prstGeom prst="roundRect">
             <a:avLst>
@@ -10322,14 +10178,14 @@
       </p:sp>
       <p:sp>
         <p:nvSpPr>
-          <p:cNvPr id="15" name="Rectangle 14"/>
+          <p:cNvPr id="14" name="Rectangle 13"/>
           <p:cNvSpPr/>
           <p:nvPr/>
         </p:nvSpPr>
         <p:spPr>
           <a:xfrm>
-            <a:off x="6342735" y="1645920"/>
-            <a:ext cx="91440" cy="1819656"/>
+            <a:off x="6342735" y="1499616"/>
+            <a:ext cx="91440" cy="1892808"/>
           </a:xfrm>
           <a:prstGeom prst="rect">
             <a:avLst/>
@@ -10366,13 +10222,13 @@
       </p:sp>
       <p:sp>
         <p:nvSpPr>
-          <p:cNvPr id="16" name="TextBox 15"/>
+          <p:cNvPr id="15" name="TextBox 14"/>
           <p:cNvSpPr txBox="1"/>
           <p:nvPr/>
         </p:nvSpPr>
         <p:spPr>
           <a:xfrm>
-            <a:off x="6589623" y="1700784"/>
+            <a:off x="6589623" y="1554480"/>
             <a:ext cx="4870551" cy="502920"/>
           </a:xfrm>
           <a:prstGeom prst="rect">
@@ -10411,14 +10267,14 @@
       </p:sp>
       <p:sp>
         <p:nvSpPr>
-          <p:cNvPr id="17" name="TextBox 16"/>
+          <p:cNvPr id="16" name="TextBox 15"/>
           <p:cNvSpPr txBox="1"/>
           <p:nvPr/>
         </p:nvSpPr>
         <p:spPr>
           <a:xfrm>
-            <a:off x="6589623" y="2313432"/>
-            <a:ext cx="4870551" cy="1078992"/>
+            <a:off x="6589623" y="2167128"/>
+            <a:ext cx="4870551" cy="1152144"/>
           </a:xfrm>
           <a:prstGeom prst="rect">
             <a:avLst/>
@@ -10456,14 +10312,14 @@
       </p:sp>
       <p:sp>
         <p:nvSpPr>
-          <p:cNvPr id="18" name="Rounded Rectangle 17"/>
+          <p:cNvPr id="17" name="Rounded Rectangle 16"/>
           <p:cNvSpPr/>
           <p:nvPr/>
         </p:nvSpPr>
         <p:spPr>
           <a:xfrm>
-            <a:off x="502920" y="3831336"/>
-            <a:ext cx="5510631" cy="2221992"/>
+            <a:off x="502920" y="3758184"/>
+            <a:ext cx="5510631" cy="2295144"/>
           </a:xfrm>
           <a:prstGeom prst="roundRect">
             <a:avLst>
@@ -10504,14 +10360,14 @@
       </p:sp>
       <p:sp>
         <p:nvSpPr>
-          <p:cNvPr id="19" name="Rectangle 18"/>
+          <p:cNvPr id="18" name="Rectangle 17"/>
           <p:cNvSpPr/>
           <p:nvPr/>
         </p:nvSpPr>
         <p:spPr>
           <a:xfrm>
-            <a:off x="667512" y="4032504"/>
-            <a:ext cx="91440" cy="1819656"/>
+            <a:off x="667512" y="3959352"/>
+            <a:ext cx="91440" cy="1892808"/>
           </a:xfrm>
           <a:prstGeom prst="rect">
             <a:avLst/>
@@ -10548,13 +10404,13 @@
       </p:sp>
       <p:sp>
         <p:nvSpPr>
-          <p:cNvPr id="20" name="TextBox 19"/>
+          <p:cNvPr id="19" name="TextBox 18"/>
           <p:cNvSpPr txBox="1"/>
           <p:nvPr/>
         </p:nvSpPr>
         <p:spPr>
           <a:xfrm>
-            <a:off x="914400" y="4087368"/>
+            <a:off x="914400" y="4014216"/>
             <a:ext cx="4870551" cy="502920"/>
           </a:xfrm>
           <a:prstGeom prst="rect">
@@ -10593,14 +10449,14 @@
       </p:sp>
       <p:sp>
         <p:nvSpPr>
-          <p:cNvPr id="21" name="TextBox 20"/>
+          <p:cNvPr id="20" name="TextBox 19"/>
           <p:cNvSpPr txBox="1"/>
           <p:nvPr/>
         </p:nvSpPr>
         <p:spPr>
           <a:xfrm>
-            <a:off x="914400" y="4700016"/>
-            <a:ext cx="4870551" cy="1078992"/>
+            <a:off x="914400" y="4626864"/>
+            <a:ext cx="4870551" cy="1152144"/>
           </a:xfrm>
           <a:prstGeom prst="rect">
             <a:avLst/>
@@ -10638,14 +10494,14 @@
       </p:sp>
       <p:sp>
         <p:nvSpPr>
-          <p:cNvPr id="22" name="Rounded Rectangle 21"/>
+          <p:cNvPr id="21" name="Rounded Rectangle 20"/>
           <p:cNvSpPr/>
           <p:nvPr/>
         </p:nvSpPr>
         <p:spPr>
           <a:xfrm>
-            <a:off x="6178143" y="3831336"/>
-            <a:ext cx="5510631" cy="2221992"/>
+            <a:off x="6178143" y="3758184"/>
+            <a:ext cx="5510631" cy="2295144"/>
           </a:xfrm>
           <a:prstGeom prst="roundRect">
             <a:avLst>
@@ -10686,14 +10542,14 @@
       </p:sp>
       <p:sp>
         <p:nvSpPr>
-          <p:cNvPr id="23" name="Rectangle 22"/>
+          <p:cNvPr id="22" name="Rectangle 21"/>
           <p:cNvSpPr/>
           <p:nvPr/>
         </p:nvSpPr>
         <p:spPr>
           <a:xfrm>
-            <a:off x="6342735" y="4032504"/>
-            <a:ext cx="91440" cy="1819656"/>
+            <a:off x="6342735" y="3959352"/>
+            <a:ext cx="91440" cy="1892808"/>
           </a:xfrm>
           <a:prstGeom prst="rect">
             <a:avLst/>
@@ -10730,13 +10586,13 @@
       </p:sp>
       <p:sp>
         <p:nvSpPr>
-          <p:cNvPr id="24" name="TextBox 23"/>
+          <p:cNvPr id="23" name="TextBox 22"/>
           <p:cNvSpPr txBox="1"/>
           <p:nvPr/>
         </p:nvSpPr>
         <p:spPr>
           <a:xfrm>
-            <a:off x="6589623" y="4087368"/>
+            <a:off x="6589623" y="4014216"/>
             <a:ext cx="4870551" cy="502920"/>
           </a:xfrm>
           <a:prstGeom prst="rect">
@@ -10775,14 +10631,14 @@
       </p:sp>
       <p:sp>
         <p:nvSpPr>
-          <p:cNvPr id="25" name="TextBox 24"/>
+          <p:cNvPr id="24" name="TextBox 23"/>
           <p:cNvSpPr txBox="1"/>
           <p:nvPr/>
         </p:nvSpPr>
         <p:spPr>
           <a:xfrm>
-            <a:off x="6589623" y="4700016"/>
-            <a:ext cx="4870551" cy="1078992"/>
+            <a:off x="6589623" y="4626864"/>
+            <a:ext cx="4870551" cy="1152144"/>
           </a:xfrm>
           <a:prstGeom prst="rect">
             <a:avLst/>
@@ -10820,7 +10676,7 @@
       </p:sp>
       <p:sp>
         <p:nvSpPr>
-          <p:cNvPr id="26" name="Rectangle 25"/>
+          <p:cNvPr id="25" name="Rectangle 24"/>
           <p:cNvSpPr/>
           <p:nvPr/>
         </p:nvSpPr>
@@ -10864,7 +10720,7 @@
       </p:sp>
       <p:sp>
         <p:nvSpPr>
-          <p:cNvPr id="27" name="TextBox 26"/>
+          <p:cNvPr id="26" name="TextBox 25"/>
           <p:cNvSpPr txBox="1"/>
           <p:nvPr/>
         </p:nvSpPr>
@@ -10909,7 +10765,7 @@
       </p:sp>
       <p:sp>
         <p:nvSpPr>
-          <p:cNvPr id="28" name="TextBox 27"/>
+          <p:cNvPr id="27" name="TextBox 26"/>
           <p:cNvSpPr txBox="1"/>
           <p:nvPr/>
         </p:nvSpPr>
@@ -11230,8 +11086,8 @@
         </p:nvSpPr>
         <p:spPr>
           <a:xfrm>
-            <a:off x="502920" y="1170432"/>
-            <a:ext cx="11185855" cy="874166"/>
+            <a:off x="502920" y="1033272"/>
+            <a:ext cx="11185855" cy="901598"/>
           </a:xfrm>
           <a:prstGeom prst="roundRect">
             <a:avLst>
@@ -11278,7 +11134,7 @@
         </p:nvSpPr>
         <p:spPr>
           <a:xfrm>
-            <a:off x="704088" y="1324051"/>
+            <a:off x="704088" y="1200607"/>
             <a:ext cx="566928" cy="566928"/>
           </a:xfrm>
           <a:prstGeom prst="roundRect">
@@ -11324,7 +11180,7 @@
         </p:nvSpPr>
         <p:spPr>
           <a:xfrm>
-            <a:off x="704088" y="1324051"/>
+            <a:off x="704088" y="1200607"/>
             <a:ext cx="566928" cy="566928"/>
           </a:xfrm>
           <a:prstGeom prst="rect">
@@ -11369,7 +11225,7 @@
         </p:nvSpPr>
         <p:spPr>
           <a:xfrm>
-            <a:off x="1527048" y="1250899"/>
+            <a:off x="1527048" y="1127455"/>
             <a:ext cx="9905695" cy="347472"/>
           </a:xfrm>
           <a:prstGeom prst="rect">
@@ -11414,7 +11270,7 @@
         </p:nvSpPr>
         <p:spPr>
           <a:xfrm>
-            <a:off x="1527048" y="1598371"/>
+            <a:off x="1527048" y="1474927"/>
             <a:ext cx="9905695" cy="347472"/>
           </a:xfrm>
           <a:prstGeom prst="rect">
@@ -11459,8 +11315,8 @@
         </p:nvSpPr>
         <p:spPr>
           <a:xfrm>
-            <a:off x="502920" y="2172614"/>
-            <a:ext cx="11185855" cy="874166"/>
+            <a:off x="502920" y="2062886"/>
+            <a:ext cx="11185855" cy="901598"/>
           </a:xfrm>
           <a:prstGeom prst="roundRect">
             <a:avLst>
@@ -11507,7 +11363,7 @@
         </p:nvSpPr>
         <p:spPr>
           <a:xfrm>
-            <a:off x="704088" y="2326233"/>
+            <a:off x="704088" y="2230221"/>
             <a:ext cx="566928" cy="566928"/>
           </a:xfrm>
           <a:prstGeom prst="roundRect">
@@ -11553,7 +11409,7 @@
         </p:nvSpPr>
         <p:spPr>
           <a:xfrm>
-            <a:off x="704088" y="2326233"/>
+            <a:off x="704088" y="2230221"/>
             <a:ext cx="566928" cy="566928"/>
           </a:xfrm>
           <a:prstGeom prst="rect">
@@ -11598,7 +11454,7 @@
         </p:nvSpPr>
         <p:spPr>
           <a:xfrm>
-            <a:off x="1527048" y="2253081"/>
+            <a:off x="1527048" y="2157069"/>
             <a:ext cx="9905695" cy="347472"/>
           </a:xfrm>
           <a:prstGeom prst="rect">
@@ -11643,7 +11499,7 @@
         </p:nvSpPr>
         <p:spPr>
           <a:xfrm>
-            <a:off x="1527048" y="2600553"/>
+            <a:off x="1527048" y="2504541"/>
             <a:ext cx="9905695" cy="347472"/>
           </a:xfrm>
           <a:prstGeom prst="rect">
@@ -11688,8 +11544,8 @@
         </p:nvSpPr>
         <p:spPr>
           <a:xfrm>
-            <a:off x="502920" y="3174796"/>
-            <a:ext cx="11185855" cy="874166"/>
+            <a:off x="502920" y="3092500"/>
+            <a:ext cx="11185855" cy="901598"/>
           </a:xfrm>
           <a:prstGeom prst="roundRect">
             <a:avLst>
@@ -11736,7 +11592,7 @@
         </p:nvSpPr>
         <p:spPr>
           <a:xfrm>
-            <a:off x="704088" y="3328415"/>
+            <a:off x="704088" y="3259835"/>
             <a:ext cx="566928" cy="566928"/>
           </a:xfrm>
           <a:prstGeom prst="roundRect">
@@ -11782,7 +11638,7 @@
         </p:nvSpPr>
         <p:spPr>
           <a:xfrm>
-            <a:off x="704088" y="3328415"/>
+            <a:off x="704088" y="3259835"/>
             <a:ext cx="566928" cy="566928"/>
           </a:xfrm>
           <a:prstGeom prst="rect">
@@ -11827,7 +11683,7 @@
         </p:nvSpPr>
         <p:spPr>
           <a:xfrm>
-            <a:off x="1527048" y="3255263"/>
+            <a:off x="1527048" y="3186683"/>
             <a:ext cx="9905695" cy="347472"/>
           </a:xfrm>
           <a:prstGeom prst="rect">
@@ -11872,7 +11728,7 @@
         </p:nvSpPr>
         <p:spPr>
           <a:xfrm>
-            <a:off x="1527048" y="3602735"/>
+            <a:off x="1527048" y="3534155"/>
             <a:ext cx="9905695" cy="347472"/>
           </a:xfrm>
           <a:prstGeom prst="rect">
@@ -11917,8 +11773,8 @@
         </p:nvSpPr>
         <p:spPr>
           <a:xfrm>
-            <a:off x="502920" y="4176979"/>
-            <a:ext cx="11185855" cy="874166"/>
+            <a:off x="502920" y="4122115"/>
+            <a:ext cx="11185855" cy="901598"/>
           </a:xfrm>
           <a:prstGeom prst="roundRect">
             <a:avLst>
@@ -11965,7 +11821,7 @@
         </p:nvSpPr>
         <p:spPr>
           <a:xfrm>
-            <a:off x="704088" y="4330598"/>
+            <a:off x="704088" y="4289450"/>
             <a:ext cx="566928" cy="566928"/>
           </a:xfrm>
           <a:prstGeom prst="roundRect">
@@ -12011,7 +11867,7 @@
         </p:nvSpPr>
         <p:spPr>
           <a:xfrm>
-            <a:off x="704088" y="4330598"/>
+            <a:off x="704088" y="4289450"/>
             <a:ext cx="566928" cy="566928"/>
           </a:xfrm>
           <a:prstGeom prst="rect">
@@ -12056,7 +11912,7 @@
         </p:nvSpPr>
         <p:spPr>
           <a:xfrm>
-            <a:off x="1527048" y="4257446"/>
+            <a:off x="1527048" y="4216298"/>
             <a:ext cx="9905695" cy="347472"/>
           </a:xfrm>
           <a:prstGeom prst="rect">
@@ -12101,7 +11957,7 @@
         </p:nvSpPr>
         <p:spPr>
           <a:xfrm>
-            <a:off x="1527048" y="4604918"/>
+            <a:off x="1527048" y="4563770"/>
             <a:ext cx="9905695" cy="347472"/>
           </a:xfrm>
           <a:prstGeom prst="rect">
@@ -12146,8 +12002,8 @@
         </p:nvSpPr>
         <p:spPr>
           <a:xfrm>
-            <a:off x="502920" y="5179161"/>
-            <a:ext cx="11185855" cy="874166"/>
+            <a:off x="502920" y="5151729"/>
+            <a:ext cx="11185855" cy="901598"/>
           </a:xfrm>
           <a:prstGeom prst="roundRect">
             <a:avLst>
@@ -12194,7 +12050,7 @@
         </p:nvSpPr>
         <p:spPr>
           <a:xfrm>
-            <a:off x="704088" y="5332780"/>
+            <a:off x="704088" y="5319064"/>
             <a:ext cx="566928" cy="566928"/>
           </a:xfrm>
           <a:prstGeom prst="roundRect">
@@ -12240,7 +12096,7 @@
         </p:nvSpPr>
         <p:spPr>
           <a:xfrm>
-            <a:off x="704088" y="5332780"/>
+            <a:off x="704088" y="5319064"/>
             <a:ext cx="566928" cy="566928"/>
           </a:xfrm>
           <a:prstGeom prst="rect">
@@ -12285,7 +12141,7 @@
         </p:nvSpPr>
         <p:spPr>
           <a:xfrm>
-            <a:off x="1527048" y="5259628"/>
+            <a:off x="1527048" y="5245912"/>
             <a:ext cx="9905695" cy="347472"/>
           </a:xfrm>
           <a:prstGeom prst="rect">
@@ -12330,7 +12186,7 @@
         </p:nvSpPr>
         <p:spPr>
           <a:xfrm>
-            <a:off x="1527048" y="5607100"/>
+            <a:off x="1527048" y="5593384"/>
             <a:ext cx="9905695" cy="347472"/>
           </a:xfrm>
           <a:prstGeom prst="rect">
@@ -12734,8 +12590,62 @@
         </p:nvSpPr>
         <p:spPr>
           <a:xfrm>
-            <a:off x="502920" y="146304"/>
-            <a:ext cx="9845942" cy="292608"/>
+            <a:off x="502920" y="256032"/>
+            <a:ext cx="9845942" cy="566928"/>
+          </a:xfrm>
+          <a:prstGeom prst="rect">
+            <a:avLst/>
+          </a:prstGeom>
+          <a:noFill/>
+        </p:spPr>
+        <p:txBody>
+          <a:bodyPr wrap="square" lIns="18000" rIns="18000" tIns="4000" bIns="4000" anchor="ctr">
+            <a:spAutoFit/>
+          </a:bodyPr>
+          <a:lstStyle/>
+          <a:p>
+            <a:pPr algn="l">
+              <a:lnSpc>
+                <a:spcPct val="115000"/>
+              </a:lnSpc>
+              <a:spcBef>
+                <a:spcPts val="0"/>
+              </a:spcBef>
+              <a:spcAft>
+                <a:spcPts val="0"/>
+              </a:spcAft>
+            </a:pPr>
+            <a:r>
+              <a:rPr sz="2800" b="1">
+                <a:solidFill>
+                  <a:srgbClr val="C45C26"/>
+                </a:solidFill>
+                <a:latin typeface="Calibri"/>
+              </a:rPr>
+              <a:t>Funding &amp; science: </a:t>
+            </a:r>
+            <a:r>
+              <a:rPr sz="2800" b="1">
+                <a:solidFill>
+                  <a:srgbClr val="0A1F2E"/>
+                </a:solidFill>
+                <a:latin typeface="Calibri"/>
+              </a:rPr>
+              <a:t>Joint research and grants</a:t>
+            </a:r>
+          </a:p>
+        </p:txBody>
+      </p:sp>
+      <p:sp>
+        <p:nvSpPr>
+          <p:cNvPr id="8" name="TextBox 7"/>
+          <p:cNvSpPr txBox="1"/>
+          <p:nvPr/>
+        </p:nvSpPr>
+        <p:spPr>
+          <a:xfrm>
+            <a:off x="502920" y="914400"/>
+            <a:ext cx="11185855" cy="384048"/>
           </a:xfrm>
           <a:prstGeom prst="rect">
             <a:avLst/>
@@ -12760,96 +12670,6 @@
               </a:spcAft>
             </a:pPr>
             <a:r>
-              <a:rPr sz="1700" b="1">
-                <a:solidFill>
-                  <a:srgbClr val="C45C26"/>
-                </a:solidFill>
-                <a:latin typeface="Calibri"/>
-              </a:rPr>
-              <a:t>FUNDING &amp; SCIENCE</a:t>
-            </a:r>
-          </a:p>
-        </p:txBody>
-      </p:sp>
-      <p:sp>
-        <p:nvSpPr>
-          <p:cNvPr id="8" name="TextBox 7"/>
-          <p:cNvSpPr txBox="1"/>
-          <p:nvPr/>
-        </p:nvSpPr>
-        <p:spPr>
-          <a:xfrm>
-            <a:off x="502920" y="402336"/>
-            <a:ext cx="9845942" cy="530352"/>
-          </a:xfrm>
-          <a:prstGeom prst="rect">
-            <a:avLst/>
-          </a:prstGeom>
-          <a:noFill/>
-        </p:spPr>
-        <p:txBody>
-          <a:bodyPr wrap="square" lIns="22000" rIns="22000" tIns="8000" bIns="8000" anchor="t">
-            <a:spAutoFit/>
-          </a:bodyPr>
-          <a:lstStyle/>
-          <a:p>
-            <a:pPr algn="l">
-              <a:lnSpc>
-                <a:spcPct val="150000"/>
-              </a:lnSpc>
-              <a:spcBef>
-                <a:spcPts val="0"/>
-              </a:spcBef>
-              <a:spcAft>
-                <a:spcPts val="0"/>
-              </a:spcAft>
-            </a:pPr>
-            <a:r>
-              <a:rPr sz="3200" b="1">
-                <a:solidFill>
-                  <a:srgbClr val="0A1F2E"/>
-                </a:solidFill>
-                <a:latin typeface="Calibri"/>
-              </a:rPr>
-              <a:t>Joint research and grants</a:t>
-            </a:r>
-          </a:p>
-        </p:txBody>
-      </p:sp>
-      <p:sp>
-        <p:nvSpPr>
-          <p:cNvPr id="9" name="TextBox 8"/>
-          <p:cNvSpPr txBox="1"/>
-          <p:nvPr/>
-        </p:nvSpPr>
-        <p:spPr>
-          <a:xfrm>
-            <a:off x="502920" y="1005840"/>
-            <a:ext cx="11185855" cy="384048"/>
-          </a:xfrm>
-          <a:prstGeom prst="rect">
-            <a:avLst/>
-          </a:prstGeom>
-          <a:noFill/>
-        </p:spPr>
-        <p:txBody>
-          <a:bodyPr wrap="square" lIns="22000" rIns="22000" tIns="8000" bIns="8000" anchor="t">
-            <a:spAutoFit/>
-          </a:bodyPr>
-          <a:lstStyle/>
-          <a:p>
-            <a:pPr algn="l">
-              <a:lnSpc>
-                <a:spcPct val="150000"/>
-              </a:lnSpc>
-              <a:spcBef>
-                <a:spcPts val="0"/>
-              </a:spcBef>
-              <a:spcAft>
-                <a:spcPts val="0"/>
-              </a:spcAft>
-            </a:pPr>
-            <a:r>
               <a:rPr sz="2000" b="0">
                 <a:solidFill>
                   <a:srgbClr val="52636C"/>
@@ -12863,14 +12683,14 @@
       </p:sp>
       <p:sp>
         <p:nvSpPr>
-          <p:cNvPr id="10" name="Rounded Rectangle 9"/>
+          <p:cNvPr id="9" name="Rounded Rectangle 8"/>
           <p:cNvSpPr/>
           <p:nvPr/>
         </p:nvSpPr>
         <p:spPr>
           <a:xfrm>
-            <a:off x="502920" y="1444752"/>
-            <a:ext cx="5702527" cy="4608576"/>
+            <a:off x="502920" y="1298448"/>
+            <a:ext cx="5702527" cy="4754880"/>
           </a:xfrm>
           <a:prstGeom prst="roundRect">
             <a:avLst>
@@ -12911,13 +12731,13 @@
       </p:sp>
       <p:sp>
         <p:nvSpPr>
-          <p:cNvPr id="11" name="TextBox 10"/>
+          <p:cNvPr id="10" name="TextBox 9"/>
           <p:cNvSpPr txBox="1"/>
           <p:nvPr/>
         </p:nvSpPr>
         <p:spPr>
           <a:xfrm>
-            <a:off x="795528" y="1700784"/>
+            <a:off x="795528" y="1554480"/>
             <a:ext cx="5153887" cy="384048"/>
           </a:xfrm>
           <a:prstGeom prst="rect">
@@ -12956,14 +12776,14 @@
       </p:sp>
       <p:sp>
         <p:nvSpPr>
-          <p:cNvPr id="12" name="TextBox 11"/>
+          <p:cNvPr id="11" name="TextBox 10"/>
           <p:cNvSpPr txBox="1"/>
           <p:nvPr/>
         </p:nvSpPr>
         <p:spPr>
           <a:xfrm>
-            <a:off x="795528" y="2267712"/>
-            <a:ext cx="5153887" cy="3557016"/>
+            <a:off x="795528" y="2121408"/>
+            <a:ext cx="5153887" cy="3703320"/>
           </a:xfrm>
           <a:prstGeom prst="rect">
             <a:avLst/>
@@ -13089,14 +12909,14 @@
       </p:sp>
       <p:sp>
         <p:nvSpPr>
-          <p:cNvPr id="13" name="Rounded Rectangle 12"/>
+          <p:cNvPr id="12" name="Rounded Rectangle 11"/>
           <p:cNvSpPr/>
           <p:nvPr/>
         </p:nvSpPr>
         <p:spPr>
           <a:xfrm>
-            <a:off x="6424903" y="1444752"/>
-            <a:ext cx="5263871" cy="4608576"/>
+            <a:off x="6424903" y="1298448"/>
+            <a:ext cx="5263871" cy="4754880"/>
           </a:xfrm>
           <a:prstGeom prst="roundRect">
             <a:avLst>
@@ -13135,13 +12955,13 @@
       </p:sp>
       <p:sp>
         <p:nvSpPr>
-          <p:cNvPr id="14" name="TextBox 13"/>
+          <p:cNvPr id="13" name="TextBox 12"/>
           <p:cNvSpPr txBox="1"/>
           <p:nvPr/>
         </p:nvSpPr>
         <p:spPr>
           <a:xfrm>
-            <a:off x="6717511" y="1764792"/>
+            <a:off x="6717511" y="1618488"/>
             <a:ext cx="4678655" cy="384048"/>
           </a:xfrm>
           <a:prstGeom prst="rect">
@@ -13180,14 +13000,14 @@
       </p:sp>
       <p:sp>
         <p:nvSpPr>
-          <p:cNvPr id="15" name="TextBox 14"/>
+          <p:cNvPr id="14" name="TextBox 13"/>
           <p:cNvSpPr txBox="1"/>
           <p:nvPr/>
         </p:nvSpPr>
         <p:spPr>
           <a:xfrm>
-            <a:off x="6717511" y="2359152"/>
-            <a:ext cx="4678655" cy="3328416"/>
+            <a:off x="6717511" y="2212848"/>
+            <a:ext cx="4678655" cy="3474720"/>
           </a:xfrm>
           <a:prstGeom prst="rect">
             <a:avLst/>
@@ -13313,7 +13133,7 @@
       </p:sp>
       <p:sp>
         <p:nvSpPr>
-          <p:cNvPr id="16" name="Rectangle 15"/>
+          <p:cNvPr id="15" name="Rectangle 14"/>
           <p:cNvSpPr/>
           <p:nvPr/>
         </p:nvSpPr>
@@ -13357,7 +13177,7 @@
       </p:sp>
       <p:sp>
         <p:nvSpPr>
-          <p:cNvPr id="17" name="TextBox 16"/>
+          <p:cNvPr id="16" name="TextBox 15"/>
           <p:cNvSpPr txBox="1"/>
           <p:nvPr/>
         </p:nvSpPr>
@@ -13402,7 +13222,7 @@
       </p:sp>
       <p:sp>
         <p:nvSpPr>
-          <p:cNvPr id="18" name="TextBox 17"/>
+          <p:cNvPr id="17" name="TextBox 16"/>
           <p:cNvSpPr txBox="1"/>
           <p:nvPr/>
         </p:nvSpPr>
@@ -13678,8 +13498,8 @@
         </p:nvSpPr>
         <p:spPr>
           <a:xfrm>
-            <a:off x="502920" y="146304"/>
-            <a:ext cx="9845942" cy="292608"/>
+            <a:off x="502920" y="256032"/>
+            <a:ext cx="9845942" cy="566928"/>
           </a:xfrm>
           <a:prstGeom prst="rect">
             <a:avLst/>
@@ -13687,14 +13507,14 @@
           <a:noFill/>
         </p:spPr>
         <p:txBody>
-          <a:bodyPr wrap="square" lIns="22000" rIns="22000" tIns="8000" bIns="8000" anchor="t">
+          <a:bodyPr wrap="square" lIns="18000" rIns="18000" tIns="4000" bIns="4000" anchor="ctr">
             <a:spAutoFit/>
           </a:bodyPr>
           <a:lstStyle/>
           <a:p>
             <a:pPr algn="l">
               <a:lnSpc>
-                <a:spcPct val="150000"/>
+                <a:spcPct val="115000"/>
               </a:lnSpc>
               <a:spcBef>
                 <a:spcPts val="0"/>
@@ -13704,52 +13524,16 @@
               </a:spcAft>
             </a:pPr>
             <a:r>
-              <a:rPr sz="1700" b="1">
+              <a:rPr sz="2800" b="1">
                 <a:solidFill>
                   <a:srgbClr val="C45C26"/>
                 </a:solidFill>
                 <a:latin typeface="Calibri"/>
               </a:rPr>
-              <a:t>NEXT STEPS</a:t>
-            </a:r>
-          </a:p>
-        </p:txBody>
-      </p:sp>
-      <p:sp>
-        <p:nvSpPr>
-          <p:cNvPr id="8" name="TextBox 7"/>
-          <p:cNvSpPr txBox="1"/>
-          <p:nvPr/>
-        </p:nvSpPr>
-        <p:spPr>
-          <a:xfrm>
-            <a:off x="502920" y="402336"/>
-            <a:ext cx="9845942" cy="530352"/>
-          </a:xfrm>
-          <a:prstGeom prst="rect">
-            <a:avLst/>
-          </a:prstGeom>
-          <a:noFill/>
-        </p:spPr>
-        <p:txBody>
-          <a:bodyPr wrap="square" lIns="22000" rIns="22000" tIns="8000" bIns="8000" anchor="t">
-            <a:spAutoFit/>
-          </a:bodyPr>
-          <a:lstStyle/>
-          <a:p>
-            <a:pPr algn="l">
-              <a:lnSpc>
-                <a:spcPct val="150000"/>
-              </a:lnSpc>
-              <a:spcBef>
-                <a:spcPts val="0"/>
-              </a:spcBef>
-              <a:spcAft>
-                <a:spcPts val="0"/>
-              </a:spcAft>
-            </a:pPr>
-            <a:r>
-              <a:rPr sz="3200" b="1">
+              <a:t>Next steps: </a:t>
+            </a:r>
+            <a:r>
+              <a:rPr sz="2800" b="1">
                 <a:solidFill>
                   <a:srgbClr val="0A1F2E"/>
                 </a:solidFill>
@@ -13762,13 +13546,13 @@
       </p:sp>
       <p:sp>
         <p:nvSpPr>
-          <p:cNvPr id="9" name="Rounded Rectangle 8"/>
+          <p:cNvPr id="8" name="Rounded Rectangle 7"/>
           <p:cNvSpPr/>
           <p:nvPr/>
         </p:nvSpPr>
         <p:spPr>
           <a:xfrm>
-            <a:off x="502920" y="1097280"/>
+            <a:off x="502920" y="960120"/>
             <a:ext cx="2673019" cy="2148840"/>
           </a:xfrm>
           <a:prstGeom prst="roundRect">
@@ -13810,13 +13594,13 @@
       </p:sp>
       <p:sp>
         <p:nvSpPr>
-          <p:cNvPr id="10" name="Rectangle 9"/>
+          <p:cNvPr id="9" name="Rectangle 8"/>
           <p:cNvSpPr/>
           <p:nvPr/>
         </p:nvSpPr>
         <p:spPr>
           <a:xfrm>
-            <a:off x="502920" y="1097280"/>
+            <a:off x="502920" y="960120"/>
             <a:ext cx="2673019" cy="868680"/>
           </a:xfrm>
           <a:prstGeom prst="rect">
@@ -13854,13 +13638,13 @@
       </p:sp>
       <p:sp>
         <p:nvSpPr>
-          <p:cNvPr id="11" name="TextBox 10"/>
+          <p:cNvPr id="10" name="TextBox 9"/>
           <p:cNvSpPr txBox="1"/>
           <p:nvPr/>
         </p:nvSpPr>
         <p:spPr>
           <a:xfrm>
-            <a:off x="630936" y="1261872"/>
+            <a:off x="630936" y="1124712"/>
             <a:ext cx="2416987" cy="292608"/>
           </a:xfrm>
           <a:prstGeom prst="rect">
@@ -13899,13 +13683,13 @@
       </p:sp>
       <p:sp>
         <p:nvSpPr>
-          <p:cNvPr id="12" name="TextBox 11"/>
+          <p:cNvPr id="11" name="TextBox 10"/>
           <p:cNvSpPr txBox="1"/>
           <p:nvPr/>
         </p:nvSpPr>
         <p:spPr>
           <a:xfrm>
-            <a:off x="630936" y="1554480"/>
+            <a:off x="630936" y="1417320"/>
             <a:ext cx="2416987" cy="329184"/>
           </a:xfrm>
           <a:prstGeom prst="rect">
@@ -13944,13 +13728,13 @@
       </p:sp>
       <p:sp>
         <p:nvSpPr>
-          <p:cNvPr id="13" name="TextBox 12"/>
+          <p:cNvPr id="12" name="TextBox 11"/>
           <p:cNvSpPr txBox="1"/>
           <p:nvPr/>
         </p:nvSpPr>
         <p:spPr>
           <a:xfrm>
-            <a:off x="630936" y="2148839"/>
+            <a:off x="630936" y="2011680"/>
             <a:ext cx="2416987" cy="914400"/>
           </a:xfrm>
           <a:prstGeom prst="rect">
@@ -13989,13 +13773,13 @@
       </p:sp>
       <p:sp>
         <p:nvSpPr>
-          <p:cNvPr id="14" name="Rounded Rectangle 13"/>
+          <p:cNvPr id="13" name="Rounded Rectangle 12"/>
           <p:cNvSpPr/>
           <p:nvPr/>
         </p:nvSpPr>
         <p:spPr>
           <a:xfrm>
-            <a:off x="3340531" y="1097280"/>
+            <a:off x="3340531" y="960120"/>
             <a:ext cx="2673019" cy="2148840"/>
           </a:xfrm>
           <a:prstGeom prst="roundRect">
@@ -14037,13 +13821,13 @@
       </p:sp>
       <p:sp>
         <p:nvSpPr>
-          <p:cNvPr id="15" name="Rectangle 14"/>
+          <p:cNvPr id="14" name="Rectangle 13"/>
           <p:cNvSpPr/>
           <p:nvPr/>
         </p:nvSpPr>
         <p:spPr>
           <a:xfrm>
-            <a:off x="3340531" y="1097280"/>
+            <a:off x="3340531" y="960120"/>
             <a:ext cx="2673019" cy="868680"/>
           </a:xfrm>
           <a:prstGeom prst="rect">
@@ -14081,13 +13865,13 @@
       </p:sp>
       <p:sp>
         <p:nvSpPr>
-          <p:cNvPr id="16" name="TextBox 15"/>
+          <p:cNvPr id="15" name="TextBox 14"/>
           <p:cNvSpPr txBox="1"/>
           <p:nvPr/>
         </p:nvSpPr>
         <p:spPr>
           <a:xfrm>
-            <a:off x="3468547" y="1261872"/>
+            <a:off x="3468547" y="1124712"/>
             <a:ext cx="2416987" cy="292608"/>
           </a:xfrm>
           <a:prstGeom prst="rect">
@@ -14126,13 +13910,13 @@
       </p:sp>
       <p:sp>
         <p:nvSpPr>
-          <p:cNvPr id="17" name="TextBox 16"/>
+          <p:cNvPr id="16" name="TextBox 15"/>
           <p:cNvSpPr txBox="1"/>
           <p:nvPr/>
         </p:nvSpPr>
         <p:spPr>
           <a:xfrm>
-            <a:off x="3468547" y="1554480"/>
+            <a:off x="3468547" y="1417320"/>
             <a:ext cx="2416987" cy="329184"/>
           </a:xfrm>
           <a:prstGeom prst="rect">
@@ -14171,13 +13955,13 @@
       </p:sp>
       <p:sp>
         <p:nvSpPr>
-          <p:cNvPr id="18" name="TextBox 17"/>
+          <p:cNvPr id="17" name="TextBox 16"/>
           <p:cNvSpPr txBox="1"/>
           <p:nvPr/>
         </p:nvSpPr>
         <p:spPr>
           <a:xfrm>
-            <a:off x="3468547" y="2148839"/>
+            <a:off x="3468547" y="2011680"/>
             <a:ext cx="2416987" cy="914400"/>
           </a:xfrm>
           <a:prstGeom prst="rect">
@@ -14216,13 +14000,13 @@
       </p:sp>
       <p:sp>
         <p:nvSpPr>
-          <p:cNvPr id="19" name="Rounded Rectangle 18"/>
+          <p:cNvPr id="18" name="Rounded Rectangle 17"/>
           <p:cNvSpPr/>
           <p:nvPr/>
         </p:nvSpPr>
         <p:spPr>
           <a:xfrm>
-            <a:off x="6178143" y="1097280"/>
+            <a:off x="6178143" y="960120"/>
             <a:ext cx="2673019" cy="2148840"/>
           </a:xfrm>
           <a:prstGeom prst="roundRect">
@@ -14264,13 +14048,13 @@
       </p:sp>
       <p:sp>
         <p:nvSpPr>
-          <p:cNvPr id="20" name="Rectangle 19"/>
+          <p:cNvPr id="19" name="Rectangle 18"/>
           <p:cNvSpPr/>
           <p:nvPr/>
         </p:nvSpPr>
         <p:spPr>
           <a:xfrm>
-            <a:off x="6178143" y="1097280"/>
+            <a:off x="6178143" y="960120"/>
             <a:ext cx="2673019" cy="868680"/>
           </a:xfrm>
           <a:prstGeom prst="rect">
@@ -14308,13 +14092,13 @@
       </p:sp>
       <p:sp>
         <p:nvSpPr>
-          <p:cNvPr id="21" name="TextBox 20"/>
+          <p:cNvPr id="20" name="TextBox 19"/>
           <p:cNvSpPr txBox="1"/>
           <p:nvPr/>
         </p:nvSpPr>
         <p:spPr>
           <a:xfrm>
-            <a:off x="6306159" y="1261872"/>
+            <a:off x="6306159" y="1124712"/>
             <a:ext cx="2416987" cy="292608"/>
           </a:xfrm>
           <a:prstGeom prst="rect">
@@ -14353,13 +14137,13 @@
       </p:sp>
       <p:sp>
         <p:nvSpPr>
-          <p:cNvPr id="22" name="TextBox 21"/>
+          <p:cNvPr id="21" name="TextBox 20"/>
           <p:cNvSpPr txBox="1"/>
           <p:nvPr/>
         </p:nvSpPr>
         <p:spPr>
           <a:xfrm>
-            <a:off x="6306159" y="1554480"/>
+            <a:off x="6306159" y="1417320"/>
             <a:ext cx="2416987" cy="329184"/>
           </a:xfrm>
           <a:prstGeom prst="rect">
@@ -14398,13 +14182,13 @@
       </p:sp>
       <p:sp>
         <p:nvSpPr>
-          <p:cNvPr id="23" name="TextBox 22"/>
+          <p:cNvPr id="22" name="TextBox 21"/>
           <p:cNvSpPr txBox="1"/>
           <p:nvPr/>
         </p:nvSpPr>
         <p:spPr>
           <a:xfrm>
-            <a:off x="6306159" y="2148839"/>
+            <a:off x="6306159" y="2011680"/>
             <a:ext cx="2416987" cy="914400"/>
           </a:xfrm>
           <a:prstGeom prst="rect">
@@ -14443,13 +14227,13 @@
       </p:sp>
       <p:sp>
         <p:nvSpPr>
-          <p:cNvPr id="24" name="Rounded Rectangle 23"/>
+          <p:cNvPr id="23" name="Rounded Rectangle 22"/>
           <p:cNvSpPr/>
           <p:nvPr/>
         </p:nvSpPr>
         <p:spPr>
           <a:xfrm>
-            <a:off x="9015755" y="1097280"/>
+            <a:off x="9015755" y="960120"/>
             <a:ext cx="2673019" cy="2148840"/>
           </a:xfrm>
           <a:prstGeom prst="roundRect">
@@ -14491,13 +14275,13 @@
       </p:sp>
       <p:sp>
         <p:nvSpPr>
-          <p:cNvPr id="25" name="Rectangle 24"/>
+          <p:cNvPr id="24" name="Rectangle 23"/>
           <p:cNvSpPr/>
           <p:nvPr/>
         </p:nvSpPr>
         <p:spPr>
           <a:xfrm>
-            <a:off x="9015755" y="1097280"/>
+            <a:off x="9015755" y="960120"/>
             <a:ext cx="2673019" cy="868680"/>
           </a:xfrm>
           <a:prstGeom prst="rect">
@@ -14535,13 +14319,13 @@
       </p:sp>
       <p:sp>
         <p:nvSpPr>
-          <p:cNvPr id="26" name="TextBox 25"/>
+          <p:cNvPr id="25" name="TextBox 24"/>
           <p:cNvSpPr txBox="1"/>
           <p:nvPr/>
         </p:nvSpPr>
         <p:spPr>
           <a:xfrm>
-            <a:off x="9143771" y="1261872"/>
+            <a:off x="9143771" y="1124712"/>
             <a:ext cx="2416987" cy="292608"/>
           </a:xfrm>
           <a:prstGeom prst="rect">
@@ -14580,13 +14364,13 @@
       </p:sp>
       <p:sp>
         <p:nvSpPr>
-          <p:cNvPr id="27" name="TextBox 26"/>
+          <p:cNvPr id="26" name="TextBox 25"/>
           <p:cNvSpPr txBox="1"/>
           <p:nvPr/>
         </p:nvSpPr>
         <p:spPr>
           <a:xfrm>
-            <a:off x="9143771" y="1554480"/>
+            <a:off x="9143771" y="1417320"/>
             <a:ext cx="2416987" cy="329184"/>
           </a:xfrm>
           <a:prstGeom prst="rect">
@@ -14625,13 +14409,13 @@
       </p:sp>
       <p:sp>
         <p:nvSpPr>
-          <p:cNvPr id="28" name="TextBox 27"/>
+          <p:cNvPr id="27" name="TextBox 26"/>
           <p:cNvSpPr txBox="1"/>
           <p:nvPr/>
         </p:nvSpPr>
         <p:spPr>
           <a:xfrm>
-            <a:off x="9143771" y="2148839"/>
+            <a:off x="9143771" y="2011680"/>
             <a:ext cx="2416987" cy="914400"/>
           </a:xfrm>
           <a:prstGeom prst="rect">
@@ -14670,14 +14454,14 @@
       </p:sp>
       <p:sp>
         <p:nvSpPr>
-          <p:cNvPr id="29" name="Rounded Rectangle 28"/>
+          <p:cNvPr id="28" name="Rounded Rectangle 27"/>
           <p:cNvSpPr/>
           <p:nvPr/>
         </p:nvSpPr>
         <p:spPr>
           <a:xfrm>
-            <a:off x="502920" y="3447288"/>
-            <a:ext cx="11185855" cy="2606040"/>
+            <a:off x="502920" y="3310128"/>
+            <a:ext cx="11185855" cy="2743199"/>
           </a:xfrm>
           <a:prstGeom prst="roundRect">
             <a:avLst>
@@ -14718,13 +14502,13 @@
       </p:sp>
       <p:sp>
         <p:nvSpPr>
-          <p:cNvPr id="30" name="TextBox 29"/>
+          <p:cNvPr id="29" name="TextBox 28"/>
           <p:cNvSpPr txBox="1"/>
           <p:nvPr/>
         </p:nvSpPr>
         <p:spPr>
           <a:xfrm>
-            <a:off x="822960" y="3593592"/>
+            <a:off x="822960" y="3456432"/>
             <a:ext cx="10545775" cy="365760"/>
           </a:xfrm>
           <a:prstGeom prst="rect">
@@ -14763,14 +14547,14 @@
       </p:sp>
       <p:sp>
         <p:nvSpPr>
-          <p:cNvPr id="31" name="TextBox 30"/>
+          <p:cNvPr id="30" name="TextBox 29"/>
           <p:cNvSpPr txBox="1"/>
           <p:nvPr/>
         </p:nvSpPr>
         <p:spPr>
           <a:xfrm>
-            <a:off x="822960" y="3995928"/>
-            <a:ext cx="10545775" cy="1920240"/>
+            <a:off x="822960" y="3858768"/>
+            <a:ext cx="10545775" cy="2057399"/>
           </a:xfrm>
           <a:prstGeom prst="rect">
             <a:avLst/>
@@ -14791,11 +14575,11 @@
                 <a:spcPts val="400"/>
               </a:spcBef>
               <a:spcAft>
-                <a:spcPts val="1400"/>
+                <a:spcPts val="1600"/>
               </a:spcAft>
             </a:pPr>
             <a:r>
-              <a:rPr sz="2000" b="0">
+              <a:rPr sz="2100" b="0">
                 <a:solidFill>
                   <a:srgbClr val="1E2F38"/>
                 </a:solidFill>
@@ -14813,11 +14597,11 @@
                 <a:spcPts val="400"/>
               </a:spcBef>
               <a:spcAft>
-                <a:spcPts val="1400"/>
+                <a:spcPts val="1600"/>
               </a:spcAft>
             </a:pPr>
             <a:r>
-              <a:rPr sz="2000" b="0">
+              <a:rPr sz="2100" b="0">
                 <a:solidFill>
                   <a:srgbClr val="1E2F38"/>
                 </a:solidFill>
@@ -14835,11 +14619,11 @@
                 <a:spcPts val="400"/>
               </a:spcBef>
               <a:spcAft>
-                <a:spcPts val="1400"/>
+                <a:spcPts val="1600"/>
               </a:spcAft>
             </a:pPr>
             <a:r>
-              <a:rPr sz="2000" b="0">
+              <a:rPr sz="2100" b="0">
                 <a:solidFill>
                   <a:srgbClr val="1E2F38"/>
                 </a:solidFill>
@@ -14852,7 +14636,7 @@
       </p:sp>
       <p:sp>
         <p:nvSpPr>
-          <p:cNvPr id="32" name="Rectangle 31"/>
+          <p:cNvPr id="31" name="Rectangle 30"/>
           <p:cNvSpPr/>
           <p:nvPr/>
         </p:nvSpPr>
@@ -14896,7 +14680,7 @@
       </p:sp>
       <p:sp>
         <p:nvSpPr>
-          <p:cNvPr id="33" name="TextBox 32"/>
+          <p:cNvPr id="32" name="TextBox 31"/>
           <p:cNvSpPr txBox="1"/>
           <p:nvPr/>
         </p:nvSpPr>
@@ -14941,7 +14725,7 @@
       </p:sp>
       <p:sp>
         <p:nvSpPr>
-          <p:cNvPr id="34" name="TextBox 33"/>
+          <p:cNvPr id="33" name="TextBox 32"/>
           <p:cNvSpPr txBox="1"/>
           <p:nvPr/>
         </p:nvSpPr>

</xml_diff>